<commit_message>
Refresh theme preview artifacts
</commit_message>
<xml_diff>
--- a/docs/theme-preview/pptx/claymorphism.pptx
+++ b/docs/theme-preview/pptx/claymorphism.pptx
@@ -3843,36 +3843,7 @@
       </p:sp>
       <p:sp>
         <p:nvSpPr>
-          <p:cNvPr id="10" name="Shape 8"/>
-          <p:cNvSpPr/>
-          <p:nvPr/>
-        </p:nvSpPr>
-        <p:spPr>
-          <a:xfrm>
-            <a:off x="9357055" y="6528816"/>
-            <a:ext cx="2148840" cy="73152"/>
-          </a:xfrm>
-          <a:prstGeom prst="rect">
-            <a:avLst/>
-          </a:prstGeom>
-          <a:solidFill>
-            <a:srgbClr val="FFFFFF">
-              <a:alpha val="90000"/>
-            </a:srgbClr>
-          </a:solidFill>
-          <a:ln w="12700">
-            <a:solidFill>
-              <a:srgbClr val="FFFFFF">
-                <a:alpha val="0"/>
-              </a:srgbClr>
-            </a:solidFill>
-            <a:prstDash val="solid"/>
-          </a:ln>
-        </p:spPr>
-      </p:sp>
-      <p:sp>
-        <p:nvSpPr>
-          <p:cNvPr id="11" name="mdpr:mdpr-design-grammar-b3a462:title:__title:mdpr-design-grammar-b3a462"/>
+          <p:cNvPr id="10" name="mdpr:mdpr-design-grammar-b3a462:title:__title:mdpr-design-grammar-b3a462"/>
           <p:cNvSpPr txBox="1"/>
           <p:nvPr/>
         </p:nvSpPr>
@@ -4164,16 +4135,148 @@
           </a:ln>
         </p:spPr>
       </p:sp>
-      <p:sp>
-        <p:nvSpPr>
-          <p:cNvPr id="9" name="Shape 7"/>
-          <p:cNvSpPr/>
-          <p:nvPr/>
-        </p:nvSpPr>
-        <p:spPr>
-          <a:xfrm>
-            <a:off x="822960" y="1554480"/>
-            <a:ext cx="4937760" cy="73152"/>
+      <p:pic>
+        <p:nvPicPr>
+          <p:cNvPr id="9" name="Image 0" descr="preencoded.png">    </p:cNvPr>
+          <p:cNvPicPr>
+            <a:picLocks noChangeAspect="1"/>
+          </p:cNvPicPr>
+          <p:nvPr/>
+        </p:nvPicPr>
+        <p:blipFill>
+          <a:blip r:embed="rId1">
+            <a:extLst>
+              <a:ext uri="{96DAC541-7B7A-43D3-8B79-37D633B846F1}">
+                <asvg:svgBlip xmlns:asvg="http://schemas.microsoft.com/office/drawing/2016/SVG/main" r:embed="rId2"/>
+              </a:ext>
+            </a:extLst>
+          </a:blip>
+          <a:stretch>
+            <a:fillRect/>
+          </a:stretch>
+        </p:blipFill>
+        <p:spPr>
+          <a:xfrm>
+            <a:off x="914400" y="2523744"/>
+            <a:ext cx="10241280" cy="1024128"/>
+          </a:xfrm>
+          <a:prstGeom prst="rect">
+            <a:avLst/>
+          </a:prstGeom>
+        </p:spPr>
+      </p:pic>
+      <p:sp>
+        <p:nvSpPr>
+          <p:cNvPr id="10" name="Shape 7"/>
+          <p:cNvSpPr/>
+          <p:nvPr/>
+        </p:nvSpPr>
+        <p:spPr>
+          <a:xfrm>
+            <a:off x="914400" y="2523744"/>
+            <a:ext cx="10241280" cy="1024128"/>
+          </a:xfrm>
+          <a:prstGeom prst="rect">
+            <a:avLst/>
+          </a:prstGeom>
+          <a:solidFill>
+            <a:srgbClr val="FFFFFF">
+              <a:alpha val="0"/>
+            </a:srgbClr>
+          </a:solidFill>
+          <a:ln w="12700">
+            <a:solidFill>
+              <a:srgbClr val="E5E7EB">
+                <a:alpha val="0"/>
+              </a:srgbClr>
+            </a:solidFill>
+            <a:prstDash val="solid"/>
+          </a:ln>
+          <a:effectLst>
+            <a:outerShdw sx="100000" sy="100000" kx="0" ky="0" algn="bl" rotWithShape="0" blurRad="12700" dist="50800" dir="2700000">
+              <a:srgbClr val="000000">
+                <a:alpha val="8000"/>
+              </a:srgbClr>
+            </a:outerShdw>
+          </a:effectLst>
+        </p:spPr>
+      </p:sp>
+      <p:pic>
+        <p:nvPicPr>
+          <p:cNvPr id="11" name="Image 1" descr="preencoded.png">    </p:cNvPr>
+          <p:cNvPicPr>
+            <a:picLocks noChangeAspect="1"/>
+          </p:cNvPicPr>
+          <p:nvPr/>
+        </p:nvPicPr>
+        <p:blipFill>
+          <a:blip r:embed="rId3">
+            <a:extLst>
+              <a:ext uri="{96DAC541-7B7A-43D3-8B79-37D633B846F1}">
+                <asvg:svgBlip xmlns:asvg="http://schemas.microsoft.com/office/drawing/2016/SVG/main" r:embed="rId4"/>
+              </a:ext>
+            </a:extLst>
+          </a:blip>
+          <a:stretch>
+            <a:fillRect/>
+          </a:stretch>
+        </p:blipFill>
+        <p:spPr>
+          <a:xfrm>
+            <a:off x="914400" y="3849624"/>
+            <a:ext cx="10241280" cy="1024128"/>
+          </a:xfrm>
+          <a:prstGeom prst="rect">
+            <a:avLst/>
+          </a:prstGeom>
+        </p:spPr>
+      </p:pic>
+      <p:sp>
+        <p:nvSpPr>
+          <p:cNvPr id="12" name="Shape 8"/>
+          <p:cNvSpPr/>
+          <p:nvPr/>
+        </p:nvSpPr>
+        <p:spPr>
+          <a:xfrm>
+            <a:off x="914400" y="3849624"/>
+            <a:ext cx="10241280" cy="1024128"/>
+          </a:xfrm>
+          <a:prstGeom prst="rect">
+            <a:avLst/>
+          </a:prstGeom>
+          <a:solidFill>
+            <a:srgbClr val="FFFFFF">
+              <a:alpha val="0"/>
+            </a:srgbClr>
+          </a:solidFill>
+          <a:ln w="12700">
+            <a:solidFill>
+              <a:srgbClr val="E5E7EB">
+                <a:alpha val="0"/>
+              </a:srgbClr>
+            </a:solidFill>
+            <a:prstDash val="solid"/>
+          </a:ln>
+          <a:effectLst>
+            <a:outerShdw sx="100000" sy="100000" kx="0" ky="0" algn="bl" rotWithShape="0" blurRad="12700" dist="50800" dir="2700000">
+              <a:srgbClr val="000000">
+                <a:alpha val="8000"/>
+              </a:srgbClr>
+            </a:outerShdw>
+          </a:effectLst>
+        </p:spPr>
+      </p:sp>
+      <p:sp>
+        <p:nvSpPr>
+          <p:cNvPr id="13" name="Shape 9"/>
+          <p:cNvSpPr/>
+          <p:nvPr/>
+        </p:nvSpPr>
+        <p:spPr>
+          <a:xfrm>
+            <a:off x="914400" y="2523744"/>
+            <a:ext cx="73152" cy="1024128"/>
           </a:xfrm>
           <a:prstGeom prst="rect">
             <a:avLst/>
@@ -4193,24 +4296,24 @@
       </p:sp>
       <p:sp>
         <p:nvSpPr>
-          <p:cNvPr id="10" name="Shape 8"/>
-          <p:cNvSpPr/>
-          <p:nvPr/>
-        </p:nvSpPr>
-        <p:spPr>
-          <a:xfrm>
-            <a:off x="6400800" y="1554480"/>
-            <a:ext cx="4937760" cy="73152"/>
-          </a:xfrm>
-          <a:prstGeom prst="rect">
-            <a:avLst/>
-          </a:prstGeom>
-          <a:solidFill>
-            <a:srgbClr val="F43F5E"/>
-          </a:solidFill>
-          <a:ln w="12700">
-            <a:solidFill>
-              <a:srgbClr val="F43F5E">
+          <p:cNvPr id="14" name="Shape 10"/>
+          <p:cNvSpPr/>
+          <p:nvPr/>
+        </p:nvSpPr>
+        <p:spPr>
+          <a:xfrm>
+            <a:off x="914400" y="3849624"/>
+            <a:ext cx="73152" cy="1024128"/>
+          </a:xfrm>
+          <a:prstGeom prst="rect">
+            <a:avLst/>
+          </a:prstGeom>
+          <a:solidFill>
+            <a:srgbClr val="38BDF8"/>
+          </a:solidFill>
+          <a:ln w="12700">
+            <a:solidFill>
+              <a:srgbClr val="38BDF8">
                 <a:alpha val="0"/>
               </a:srgbClr>
             </a:solidFill>
@@ -4220,7 +4323,7 @@
       </p:sp>
       <p:sp>
         <p:nvSpPr>
-          <p:cNvPr id="11" name="mdpr:2-2-a9df10:title:__title:2-2-a9df10"/>
+          <p:cNvPr id="15" name="mdpr:2-2-a9df10:title:__title:2-2-a9df10"/>
           <p:cNvSpPr txBox="1"/>
           <p:nvPr/>
         </p:nvSpPr>
@@ -4254,7 +4357,24 @@
                 <a:ea typeface="Pretendard" pitchFamily="34" charset="-122"/>
                 <a:cs typeface="Pretendard" pitchFamily="34" charset="-120"/>
               </a:rPr>
-              <a:t>Semantic Blocks (Cont. 2/2)</a:t>
+              <a:t>Semantic Blocks</a:t>
+            </a:r>
+            <a:pPr algn="ctr" indent="0" marL="0">
+              <a:lnSpc>
+                <a:spcPct val="120000"/>
+              </a:lnSpc>
+              <a:buNone/>
+            </a:pPr>
+            <a:r>
+              <a:rPr lang="en-US" sz="2000" dirty="0">
+                <a:solidFill>
+                  <a:srgbClr val="8F8F8F"/>
+                </a:solidFill>
+                <a:latin typeface="Pretendard" pitchFamily="34" charset="0"/>
+                <a:ea typeface="Pretendard" pitchFamily="34" charset="-122"/>
+                <a:cs typeface="Pretendard" pitchFamily="34" charset="-120"/>
+              </a:rPr>
+              <a:t> (Cont. 2/2)</a:t>
             </a:r>
             <a:endParaRPr lang="en-US" sz="3400" dirty="0"/>
           </a:p>
@@ -4262,14 +4382,14 @@
       </p:sp>
       <p:sp>
         <p:nvSpPr>
-          <p:cNvPr id="12" name="mdpr:2-2-a9df10:left:block-10-chunk-2"/>
+          <p:cNvPr id="16" name="mdpr:2-2-a9df10:item-1:block-10-chunk-2"/>
           <p:cNvSpPr txBox="1"/>
           <p:nvPr/>
         </p:nvSpPr>
         <p:spPr>
           <a:xfrm>
-            <a:off x="896112" y="1664208"/>
-            <a:ext cx="4791456" cy="4169664"/>
+            <a:off x="1133856" y="2615916"/>
+            <a:ext cx="9820656" cy="839785"/>
           </a:xfrm>
           <a:prstGeom prst="rect">
             <a:avLst/>
@@ -4278,7 +4398,7 @@
           <a:ln/>
         </p:spPr>
         <p:txBody>
-          <a:bodyPr wrap="square" lIns="0" tIns="25400" rIns="25400" bIns="0" rtlCol="0" anchor="t"/>
+          <a:bodyPr wrap="square" lIns="0" tIns="25400" rIns="25400" bIns="0" rtlCol="0" anchor="ctr"/>
           <a:lstStyle/>
           <a:p>
             <a:pPr algn="l" indent="0" marL="0">
@@ -4296,7 +4416,7 @@
                 <a:ea typeface="Pretendard" pitchFamily="34" charset="-122"/>
                 <a:cs typeface="Pretendard" pitchFamily="34" charset="-120"/>
               </a:rPr>
-              <a:t>- Constraint:</a:t>
+              <a:t>Constraint:</a:t>
             </a:r>
             <a:pPr algn="l" indent="0" marL="0">
               <a:lnSpc>
@@ -4321,14 +4441,14 @@
       </p:sp>
       <p:sp>
         <p:nvSpPr>
-          <p:cNvPr id="13" name="mdpr:2-2-a9df10:right:block-10-chunk-2"/>
+          <p:cNvPr id="17" name="mdpr:2-2-a9df10:item-2:block-10-chunk-2"/>
           <p:cNvSpPr txBox="1"/>
           <p:nvPr/>
         </p:nvSpPr>
         <p:spPr>
           <a:xfrm>
-            <a:off x="6473952" y="1664208"/>
-            <a:ext cx="4791456" cy="4169664"/>
+            <a:off x="1133856" y="3941796"/>
+            <a:ext cx="9820656" cy="839785"/>
           </a:xfrm>
           <a:prstGeom prst="rect">
             <a:avLst/>
@@ -4337,7 +4457,7 @@
           <a:ln/>
         </p:spPr>
         <p:txBody>
-          <a:bodyPr wrap="square" lIns="0" tIns="25400" rIns="25400" bIns="0" rtlCol="0" anchor="t"/>
+          <a:bodyPr wrap="square" lIns="0" tIns="25400" rIns="25400" bIns="0" rtlCol="0" anchor="ctr"/>
           <a:lstStyle/>
           <a:p>
             <a:pPr algn="l" indent="0" marL="0">
@@ -4355,7 +4475,7 @@
                 <a:ea typeface="Pretendard" pitchFamily="34" charset="-122"/>
                 <a:cs typeface="Pretendard" pitchFamily="34" charset="-120"/>
               </a:rPr>
-              <a:t>- Emphasis</a:t>
+              <a:t>Emphasis</a:t>
             </a:r>
             <a:pPr algn="l" indent="0" marL="0">
               <a:lnSpc>
@@ -4910,7 +5030,7 @@
               <a:buNone/>
             </a:pPr>
             <a:r>
-              <a:rPr lang="en-US" sz="1500" b="1" dirty="0">
+              <a:rPr lang="en-US" sz="1600" b="1" dirty="0">
                 <a:solidFill>
                   <a:srgbClr val="F6F7FB"/>
                 </a:solidFill>
@@ -4920,7 +5040,7 @@
               </a:rPr>
               <a:t>1</a:t>
             </a:r>
-            <a:endParaRPr lang="en-US" sz="1500" dirty="0"/>
+            <a:endParaRPr lang="en-US" sz="1600" dirty="0"/>
           </a:p>
         </p:txBody>
       </p:sp>
@@ -5086,7 +5206,7 @@
               <a:buNone/>
             </a:pPr>
             <a:r>
-              <a:rPr lang="en-US" sz="1500" b="1" dirty="0">
+              <a:rPr lang="en-US" sz="1600" b="1" dirty="0">
                 <a:solidFill>
                   <a:srgbClr val="F6F7FB"/>
                 </a:solidFill>
@@ -5096,7 +5216,7 @@
               </a:rPr>
               <a:t>2</a:t>
             </a:r>
-            <a:endParaRPr lang="en-US" sz="1500" dirty="0"/>
+            <a:endParaRPr lang="en-US" sz="1600" dirty="0"/>
           </a:p>
         </p:txBody>
       </p:sp>
@@ -5262,7 +5382,7 @@
               <a:buNone/>
             </a:pPr>
             <a:r>
-              <a:rPr lang="en-US" sz="1500" b="1" dirty="0">
+              <a:rPr lang="en-US" sz="1600" b="1" dirty="0">
                 <a:solidFill>
                   <a:srgbClr val="F6F7FB"/>
                 </a:solidFill>
@@ -5272,7 +5392,7 @@
               </a:rPr>
               <a:t>3</a:t>
             </a:r>
-            <a:endParaRPr lang="en-US" sz="1500" dirty="0"/>
+            <a:endParaRPr lang="en-US" sz="1600" dirty="0"/>
           </a:p>
         </p:txBody>
       </p:sp>
@@ -5438,7 +5558,7 @@
               <a:buNone/>
             </a:pPr>
             <a:r>
-              <a:rPr lang="en-US" sz="1500" b="1" dirty="0">
+              <a:rPr lang="en-US" sz="1600" b="1" dirty="0">
                 <a:solidFill>
                   <a:srgbClr val="F6F7FB"/>
                 </a:solidFill>
@@ -5448,7 +5568,7 @@
               </a:rPr>
               <a:t>4</a:t>
             </a:r>
-            <a:endParaRPr lang="en-US" sz="1500" dirty="0"/>
+            <a:endParaRPr lang="en-US" sz="1600" dirty="0"/>
           </a:p>
         </p:txBody>
       </p:sp>
@@ -5614,7 +5734,7 @@
               <a:buNone/>
             </a:pPr>
             <a:r>
-              <a:rPr lang="en-US" sz="1500" b="1" dirty="0">
+              <a:rPr lang="en-US" sz="1600" b="1" dirty="0">
                 <a:solidFill>
                   <a:srgbClr val="F6F7FB"/>
                 </a:solidFill>
@@ -5624,7 +5744,7 @@
               </a:rPr>
               <a:t>5</a:t>
             </a:r>
-            <a:endParaRPr lang="en-US" sz="1500" dirty="0"/>
+            <a:endParaRPr lang="en-US" sz="1600" dirty="0"/>
           </a:p>
         </p:txBody>
       </p:sp>
@@ -5790,7 +5910,7 @@
               <a:buNone/>
             </a:pPr>
             <a:r>
-              <a:rPr lang="en-US" sz="1500" b="1" dirty="0">
+              <a:rPr lang="en-US" sz="1600" b="1" dirty="0">
                 <a:solidFill>
                   <a:srgbClr val="F6F7FB"/>
                 </a:solidFill>
@@ -5800,7 +5920,7 @@
               </a:rPr>
               <a:t>6</a:t>
             </a:r>
-            <a:endParaRPr lang="en-US" sz="1500" dirty="0"/>
+            <a:endParaRPr lang="en-US" sz="1600" dirty="0"/>
           </a:p>
         </p:txBody>
       </p:sp>
@@ -6102,61 +6222,7 @@
       </p:sp>
       <p:sp>
         <p:nvSpPr>
-          <p:cNvPr id="9" name="Shape 7"/>
-          <p:cNvSpPr/>
-          <p:nvPr/>
-        </p:nvSpPr>
-        <p:spPr>
-          <a:xfrm>
-            <a:off x="822960" y="1389888"/>
-            <a:ext cx="4937760" cy="73152"/>
-          </a:xfrm>
-          <a:prstGeom prst="rect">
-            <a:avLst/>
-          </a:prstGeom>
-          <a:solidFill>
-            <a:srgbClr val="F43F5E"/>
-          </a:solidFill>
-          <a:ln w="12700">
-            <a:solidFill>
-              <a:srgbClr val="F43F5E">
-                <a:alpha val="0"/>
-              </a:srgbClr>
-            </a:solidFill>
-            <a:prstDash val="solid"/>
-          </a:ln>
-        </p:spPr>
-      </p:sp>
-      <p:sp>
-        <p:nvSpPr>
-          <p:cNvPr id="10" name="Shape 8"/>
-          <p:cNvSpPr/>
-          <p:nvPr/>
-        </p:nvSpPr>
-        <p:spPr>
-          <a:xfrm>
-            <a:off x="6400800" y="1389888"/>
-            <a:ext cx="4937760" cy="73152"/>
-          </a:xfrm>
-          <a:prstGeom prst="rect">
-            <a:avLst/>
-          </a:prstGeom>
-          <a:solidFill>
-            <a:srgbClr val="F43F5E"/>
-          </a:solidFill>
-          <a:ln w="12700">
-            <a:solidFill>
-              <a:srgbClr val="F43F5E">
-                <a:alpha val="0"/>
-              </a:srgbClr>
-            </a:solidFill>
-            <a:prstDash val="solid"/>
-          </a:ln>
-        </p:spPr>
-      </p:sp>
-      <p:sp>
-        <p:nvSpPr>
-          <p:cNvPr id="11" name="mdpr:1-2-e3669a:title:__title:1-2-e3669a"/>
+          <p:cNvPr id="9" name="mdpr:1-2-e3669a:title:__title:1-2-e3669a"/>
           <p:cNvSpPr txBox="1"/>
           <p:nvPr/>
         </p:nvSpPr>
@@ -6198,14 +6264,14 @@
       </p:sp>
       <p:sp>
         <p:nvSpPr>
-          <p:cNvPr id="12" name="mdpr:1-2-e3669a:left:block-15-chunk-1-block-15-chunk-1"/>
+          <p:cNvPr id="10" name="mdpr:1-2-e3669a:left:block-15-chunk-1-block-15-chunk-1"/>
           <p:cNvSpPr txBox="1"/>
           <p:nvPr/>
         </p:nvSpPr>
         <p:spPr>
           <a:xfrm>
-            <a:off x="896112" y="1499616"/>
-            <a:ext cx="4791456" cy="4398264"/>
+            <a:off x="896112" y="1463040"/>
+            <a:ext cx="4791456" cy="4261104"/>
           </a:xfrm>
           <a:prstGeom prst="rect">
             <a:avLst/>
@@ -6297,14 +6363,14 @@
       </p:sp>
       <p:sp>
         <p:nvSpPr>
-          <p:cNvPr id="13" name="mdpr:1-2-e3669a:right:block-15-chunk-1-block-15-chunk-1"/>
+          <p:cNvPr id="11" name="mdpr:1-2-e3669a:right:block-15-chunk-1"/>
           <p:cNvSpPr txBox="1"/>
           <p:nvPr/>
         </p:nvSpPr>
         <p:spPr>
           <a:xfrm>
-            <a:off x="6473952" y="1499616"/>
-            <a:ext cx="4791456" cy="4398264"/>
+            <a:off x="6473952" y="1463040"/>
+            <a:ext cx="4791456" cy="4261104"/>
           </a:xfrm>
           <a:prstGeom prst="rect">
             <a:avLst/>
@@ -6352,46 +6418,6 @@
             </a:r>
             <a:endParaRPr lang="en-US" sz="1800" dirty="0"/>
           </a:p>
-          <a:p>
-            <a:pPr algn="l" indent="0" marL="0">
-              <a:lnSpc>
-                <a:spcPct val="120000"/>
-              </a:lnSpc>
-              <a:buNone/>
-            </a:pPr>
-            <a:r>
-              <a:rPr lang="en-US" sz="1800" b="1" dirty="0">
-                <a:solidFill>
-                  <a:srgbClr val="F43F5E"/>
-                </a:solidFill>
-                <a:latin typeface="Pretendard" pitchFamily="34" charset="0"/>
-                <a:ea typeface="Pretendard" pitchFamily="34" charset="-122"/>
-                <a:cs typeface="Pretendard" pitchFamily="34" charset="-120"/>
-              </a:rPr>
-              <a:t>- Connectors</a:t>
-            </a:r>
-            <a:endParaRPr lang="en-US" sz="1800" dirty="0"/>
-          </a:p>
-          <a:p>
-            <a:pPr algn="l" indent="0" marL="0">
-              <a:lnSpc>
-                <a:spcPct val="120000"/>
-              </a:lnSpc>
-              <a:buNone/>
-            </a:pPr>
-            <a:r>
-              <a:rPr lang="en-US" sz="1800" dirty="0">
-                <a:solidFill>
-                  <a:srgbClr val="111111"/>
-                </a:solidFill>
-                <a:latin typeface="Pretendard" pitchFamily="34" charset="0"/>
-                <a:ea typeface="Pretendard" pitchFamily="34" charset="-122"/>
-                <a:cs typeface="Pretendard" pitchFamily="34" charset="-120"/>
-              </a:rPr>
-              <a:t>  straight-arrow, elbow-arrow, boundary-attach, overlap-joint, parallel-flow, contrast-flow.</a:t>
-            </a:r>
-            <a:endParaRPr lang="en-US" sz="1800" dirty="0"/>
-          </a:p>
         </p:txBody>
       </p:sp>
     </p:spTree>
@@ -6648,61 +6674,7 @@
       </p:sp>
       <p:sp>
         <p:nvSpPr>
-          <p:cNvPr id="9" name="Shape 7"/>
-          <p:cNvSpPr/>
-          <p:nvPr/>
-        </p:nvSpPr>
-        <p:spPr>
-          <a:xfrm>
-            <a:off x="822960" y="1554480"/>
-            <a:ext cx="4937760" cy="73152"/>
-          </a:xfrm>
-          <a:prstGeom prst="rect">
-            <a:avLst/>
-          </a:prstGeom>
-          <a:solidFill>
-            <a:srgbClr val="F43F5E"/>
-          </a:solidFill>
-          <a:ln w="12700">
-            <a:solidFill>
-              <a:srgbClr val="F43F5E">
-                <a:alpha val="0"/>
-              </a:srgbClr>
-            </a:solidFill>
-            <a:prstDash val="solid"/>
-          </a:ln>
-        </p:spPr>
-      </p:sp>
-      <p:sp>
-        <p:nvSpPr>
-          <p:cNvPr id="10" name="Shape 8"/>
-          <p:cNvSpPr/>
-          <p:nvPr/>
-        </p:nvSpPr>
-        <p:spPr>
-          <a:xfrm>
-            <a:off x="6400800" y="1554480"/>
-            <a:ext cx="4937760" cy="73152"/>
-          </a:xfrm>
-          <a:prstGeom prst="rect">
-            <a:avLst/>
-          </a:prstGeom>
-          <a:solidFill>
-            <a:srgbClr val="F43F5E"/>
-          </a:solidFill>
-          <a:ln w="12700">
-            <a:solidFill>
-              <a:srgbClr val="F43F5E">
-                <a:alpha val="0"/>
-              </a:srgbClr>
-            </a:solidFill>
-            <a:prstDash val="solid"/>
-          </a:ln>
-        </p:spPr>
-      </p:sp>
-      <p:sp>
-        <p:nvSpPr>
-          <p:cNvPr id="11" name="mdpr:2-2-c23e9b:title:__title:2-2-c23e9b"/>
+          <p:cNvPr id="9" name="mdpr:2-2-c23e9b:title:__title:2-2-c23e9b"/>
           <p:cNvSpPr txBox="1"/>
           <p:nvPr/>
         </p:nvSpPr>
@@ -6736,7 +6708,24 @@
                 <a:ea typeface="Pretendard" pitchFamily="34" charset="-122"/>
                 <a:cs typeface="Pretendard" pitchFamily="34" charset="-120"/>
               </a:rPr>
-              <a:t>Decoration Pattern Catalog (Cont. 2/2)</a:t>
+              <a:t>Decoration Pattern Catalog</a:t>
+            </a:r>
+            <a:pPr algn="ctr" indent="0" marL="0">
+              <a:lnSpc>
+                <a:spcPct val="120000"/>
+              </a:lnSpc>
+              <a:buNone/>
+            </a:pPr>
+            <a:r>
+              <a:rPr lang="en-US" sz="2000" dirty="0">
+                <a:solidFill>
+                  <a:srgbClr val="8F8F8F"/>
+                </a:solidFill>
+                <a:latin typeface="Pretendard" pitchFamily="34" charset="0"/>
+                <a:ea typeface="Pretendard" pitchFamily="34" charset="-122"/>
+                <a:cs typeface="Pretendard" pitchFamily="34" charset="-120"/>
+              </a:rPr>
+              <a:t> (Cont. 2/2)</a:t>
             </a:r>
             <a:endParaRPr lang="en-US" sz="3400" dirty="0"/>
           </a:p>
@@ -6744,14 +6733,14 @@
       </p:sp>
       <p:sp>
         <p:nvSpPr>
-          <p:cNvPr id="12" name="mdpr:2-2-c23e9b:left:block-15-chunk-2"/>
+          <p:cNvPr id="10" name="mdpr:2-2-c23e9b:left:block-15-chunk-2-block-15-chunk-2"/>
           <p:cNvSpPr txBox="1"/>
           <p:nvPr/>
         </p:nvSpPr>
         <p:spPr>
           <a:xfrm>
-            <a:off x="896112" y="1664208"/>
-            <a:ext cx="4791456" cy="4169664"/>
+            <a:off x="896112" y="1463040"/>
+            <a:ext cx="4791456" cy="4261104"/>
           </a:xfrm>
           <a:prstGeom prst="rect">
             <a:avLst/>
@@ -6770,7 +6759,44 @@
               <a:buNone/>
             </a:pPr>
             <a:r>
-              <a:rPr lang="en-US" sz="2200" b="1" dirty="0">
+              <a:rPr lang="en-US" sz="1800" b="1" dirty="0">
+                <a:solidFill>
+                  <a:srgbClr val="F43F5E"/>
+                </a:solidFill>
+                <a:latin typeface="Pretendard" pitchFamily="34" charset="0"/>
+                <a:ea typeface="Pretendard" pitchFamily="34" charset="-122"/>
+                <a:cs typeface="Pretendard" pitchFamily="34" charset="-120"/>
+              </a:rPr>
+              <a:t>- Connectors</a:t>
+            </a:r>
+            <a:pPr algn="l" indent="0" marL="0">
+              <a:lnSpc>
+                <a:spcPct val="120000"/>
+              </a:lnSpc>
+              <a:buNone/>
+            </a:pPr>
+            <a:r>
+              <a:rPr lang="en-US" sz="1800" dirty="0">
+                <a:solidFill>
+                  <a:srgbClr val="111111"/>
+                </a:solidFill>
+                <a:latin typeface="Pretendard" pitchFamily="34" charset="0"/>
+                <a:ea typeface="Pretendard" pitchFamily="34" charset="-122"/>
+                <a:cs typeface="Pretendard" pitchFamily="34" charset="-120"/>
+              </a:rPr>
+              <a:t>  straight-arrow, elbow-arrow, boundary-attach, overlap-joint, parallel-flow, contrast-flow.</a:t>
+            </a:r>
+            <a:endParaRPr lang="en-US" sz="1800" dirty="0"/>
+          </a:p>
+          <a:p>
+            <a:pPr algn="l" indent="0" marL="0">
+              <a:lnSpc>
+                <a:spcPct val="120000"/>
+              </a:lnSpc>
+              <a:buNone/>
+            </a:pPr>
+            <a:r>
+              <a:rPr lang="en-US" sz="1800" b="1" dirty="0">
                 <a:solidFill>
                   <a:srgbClr val="F43F5E"/>
                 </a:solidFill>
@@ -6780,6 +6806,9 @@
               </a:rPr>
               <a:t>- Icons</a:t>
             </a:r>
+            <a:endParaRPr lang="en-US" sz="1800" dirty="0"/>
+          </a:p>
+          <a:p>
             <a:pPr algn="l" indent="0" marL="0">
               <a:lnSpc>
                 <a:spcPct val="120000"/>
@@ -6787,7 +6816,7 @@
               <a:buNone/>
             </a:pPr>
             <a:r>
-              <a:rPr lang="en-US" sz="2200" dirty="0">
+              <a:rPr lang="en-US" sz="1800" dirty="0">
                 <a:solidFill>
                   <a:srgbClr val="111111"/>
                 </a:solidFill>
@@ -6797,20 +6826,20 @@
               </a:rPr>
               <a:t>  number-badge, mono-icon-slot, letter-disc, quiet-aside, image-safe-frame, brand-glyph.</a:t>
             </a:r>
-            <a:endParaRPr lang="en-US" sz="2200" dirty="0"/>
+            <a:endParaRPr lang="en-US" sz="1800" dirty="0"/>
           </a:p>
         </p:txBody>
       </p:sp>
       <p:sp>
         <p:nvSpPr>
-          <p:cNvPr id="13" name="mdpr:2-2-c23e9b:right:block-15-chunk-2"/>
+          <p:cNvPr id="11" name="mdpr:2-2-c23e9b:right:block-15-chunk-2"/>
           <p:cNvSpPr txBox="1"/>
           <p:nvPr/>
         </p:nvSpPr>
         <p:spPr>
           <a:xfrm>
-            <a:off x="6473952" y="1664208"/>
-            <a:ext cx="4791456" cy="4169664"/>
+            <a:off x="6473952" y="1463040"/>
+            <a:ext cx="4791456" cy="4261104"/>
           </a:xfrm>
           <a:prstGeom prst="rect">
             <a:avLst/>
@@ -6829,7 +6858,7 @@
               <a:buNone/>
             </a:pPr>
             <a:r>
-              <a:rPr lang="en-US" sz="2200" b="1" dirty="0">
+              <a:rPr lang="en-US" sz="1800" b="1" dirty="0">
                 <a:solidFill>
                   <a:srgbClr val="F43F5E"/>
                 </a:solidFill>
@@ -6846,7 +6875,7 @@
               <a:buNone/>
             </a:pPr>
             <a:r>
-              <a:rPr lang="en-US" sz="2200" dirty="0">
+              <a:rPr lang="en-US" sz="1800" dirty="0">
                 <a:solidFill>
                   <a:srgbClr val="111111"/>
                 </a:solidFill>
@@ -6856,7 +6885,7 @@
               </a:rPr>
               <a:t>  skeuomorphic-bevel, glassmorphism-surface, newmorphic-panel, clay-blob, bento-tile, liquid-lens.</a:t>
             </a:r>
-            <a:endParaRPr lang="en-US" sz="2200" dirty="0"/>
+            <a:endParaRPr lang="en-US" sz="1800" dirty="0"/>
           </a:p>
         </p:txBody>
       </p:sp>
@@ -9171,7 +9200,24 @@
                 <a:ea typeface="Pretendard" pitchFamily="34" charset="-122"/>
                 <a:cs typeface="Pretendard" pitchFamily="34" charset="-120"/>
               </a:rPr>
-              <a:t>Chart and Table Pair (Cont. 2/2)</a:t>
+              <a:t>Chart and Table Pair</a:t>
+            </a:r>
+            <a:pPr algn="ctr" indent="0" marL="0">
+              <a:lnSpc>
+                <a:spcPct val="120000"/>
+              </a:lnSpc>
+              <a:buNone/>
+            </a:pPr>
+            <a:r>
+              <a:rPr lang="en-US" sz="2000" dirty="0">
+                <a:solidFill>
+                  <a:srgbClr val="8F8F8F"/>
+                </a:solidFill>
+                <a:latin typeface="Pretendard" pitchFamily="34" charset="0"/>
+                <a:ea typeface="Pretendard" pitchFamily="34" charset="-122"/>
+                <a:cs typeface="Pretendard" pitchFamily="34" charset="-120"/>
+              </a:rPr>
+              <a:t> (Cont. 2/2)</a:t>
             </a:r>
             <a:endParaRPr lang="en-US" sz="3400" dirty="0"/>
           </a:p>
@@ -11437,7 +11483,24 @@
                 <a:ea typeface="Pretendard" pitchFamily="34" charset="-122"/>
                 <a:cs typeface="Pretendard" pitchFamily="34" charset="-120"/>
               </a:rPr>
-              <a:t>Editable Proof Objects (Cont. 2/2)</a:t>
+              <a:t>Editable Proof Objects</a:t>
+            </a:r>
+            <a:pPr algn="ctr" indent="0" marL="0">
+              <a:lnSpc>
+                <a:spcPct val="120000"/>
+              </a:lnSpc>
+              <a:buNone/>
+            </a:pPr>
+            <a:r>
+              <a:rPr lang="en-US" sz="2000" dirty="0">
+                <a:solidFill>
+                  <a:srgbClr val="8F8F8F"/>
+                </a:solidFill>
+                <a:latin typeface="Pretendard" pitchFamily="34" charset="0"/>
+                <a:ea typeface="Pretendard" pitchFamily="34" charset="-122"/>
+                <a:cs typeface="Pretendard" pitchFamily="34" charset="-120"/>
+              </a:rPr>
+              <a:t> (Cont. 2/2)</a:t>
             </a:r>
             <a:endParaRPr lang="en-US" sz="3400" dirty="0"/>
           </a:p>
@@ -12335,222 +12398,49 @@
           </a:ln>
         </p:spPr>
       </p:sp>
-      <p:pic>
-        <p:nvPicPr>
-          <p:cNvPr id="9" name="Image 0" descr="preencoded.png">    </p:cNvPr>
-          <p:cNvPicPr>
-            <a:picLocks noChangeAspect="1"/>
-          </p:cNvPicPr>
-          <p:nvPr/>
-        </p:nvPicPr>
-        <p:blipFill>
-          <a:blip r:embed="rId1">
-            <a:extLst>
-              <a:ext uri="{96DAC541-7B7A-43D3-8B79-37D633B846F1}">
-                <asvg:svgBlip xmlns:asvg="http://schemas.microsoft.com/office/drawing/2016/SVG/main" r:embed="rId2"/>
-              </a:ext>
-            </a:extLst>
-          </a:blip>
-          <a:stretch>
-            <a:fillRect/>
-          </a:stretch>
-        </p:blipFill>
-        <p:spPr>
-          <a:xfrm>
-            <a:off x="914400" y="1865376"/>
-            <a:ext cx="10241280" cy="1024128"/>
-          </a:xfrm>
-          <a:prstGeom prst="rect">
-            <a:avLst/>
-          </a:prstGeom>
-        </p:spPr>
-      </p:pic>
-      <p:sp>
-        <p:nvSpPr>
-          <p:cNvPr id="10" name="Shape 7"/>
-          <p:cNvSpPr/>
-          <p:nvPr/>
-        </p:nvSpPr>
-        <p:spPr>
-          <a:xfrm>
-            <a:off x="914400" y="1865376"/>
-            <a:ext cx="10241280" cy="1024128"/>
-          </a:xfrm>
-          <a:prstGeom prst="rect">
-            <a:avLst/>
-          </a:prstGeom>
-          <a:solidFill>
-            <a:srgbClr val="FFFFFF">
-              <a:alpha val="0"/>
-            </a:srgbClr>
-          </a:solidFill>
-          <a:ln w="12700">
-            <a:solidFill>
-              <a:srgbClr val="E5E7EB">
+      <p:sp>
+        <p:nvSpPr>
+          <p:cNvPr id="9" name="Shape 7"/>
+          <p:cNvSpPr/>
+          <p:nvPr/>
+        </p:nvSpPr>
+        <p:spPr>
+          <a:xfrm>
+            <a:off x="822960" y="1938528"/>
+            <a:ext cx="73152" cy="2514600"/>
+          </a:xfrm>
+          <a:prstGeom prst="rect">
+            <a:avLst/>
+          </a:prstGeom>
+          <a:solidFill>
+            <a:srgbClr val="F43F5E"/>
+          </a:solidFill>
+          <a:ln w="12700">
+            <a:solidFill>
+              <a:srgbClr val="F43F5E">
                 <a:alpha val="0"/>
               </a:srgbClr>
             </a:solidFill>
             <a:prstDash val="solid"/>
           </a:ln>
-          <a:effectLst>
-            <a:outerShdw sx="100000" sy="100000" kx="0" ky="0" algn="bl" rotWithShape="0" blurRad="12700" dist="50800" dir="2700000">
-              <a:srgbClr val="000000">
-                <a:alpha val="8000"/>
-              </a:srgbClr>
-            </a:outerShdw>
-          </a:effectLst>
-        </p:spPr>
-      </p:sp>
-      <p:pic>
-        <p:nvPicPr>
-          <p:cNvPr id="11" name="Image 1" descr="preencoded.png">    </p:cNvPr>
-          <p:cNvPicPr>
-            <a:picLocks noChangeAspect="1"/>
-          </p:cNvPicPr>
-          <p:nvPr/>
-        </p:nvPicPr>
-        <p:blipFill>
-          <a:blip r:embed="rId3">
-            <a:extLst>
-              <a:ext uri="{96DAC541-7B7A-43D3-8B79-37D633B846F1}">
-                <asvg:svgBlip xmlns:asvg="http://schemas.microsoft.com/office/drawing/2016/SVG/main" r:embed="rId4"/>
-              </a:ext>
-            </a:extLst>
-          </a:blip>
-          <a:stretch>
-            <a:fillRect/>
-          </a:stretch>
-        </p:blipFill>
-        <p:spPr>
-          <a:xfrm>
-            <a:off x="914400" y="3191256"/>
-            <a:ext cx="10241280" cy="1024128"/>
-          </a:xfrm>
-          <a:prstGeom prst="rect">
-            <a:avLst/>
-          </a:prstGeom>
-        </p:spPr>
-      </p:pic>
-      <p:sp>
-        <p:nvSpPr>
-          <p:cNvPr id="12" name="Shape 8"/>
-          <p:cNvSpPr/>
-          <p:nvPr/>
-        </p:nvSpPr>
-        <p:spPr>
-          <a:xfrm>
-            <a:off x="914400" y="3191256"/>
-            <a:ext cx="10241280" cy="1024128"/>
-          </a:xfrm>
-          <a:prstGeom prst="rect">
-            <a:avLst/>
-          </a:prstGeom>
-          <a:solidFill>
-            <a:srgbClr val="FFFFFF">
-              <a:alpha val="0"/>
-            </a:srgbClr>
-          </a:solidFill>
-          <a:ln w="12700">
-            <a:solidFill>
-              <a:srgbClr val="E5E7EB">
-                <a:alpha val="0"/>
-              </a:srgbClr>
-            </a:solidFill>
-            <a:prstDash val="solid"/>
-          </a:ln>
-          <a:effectLst>
-            <a:outerShdw sx="100000" sy="100000" kx="0" ky="0" algn="bl" rotWithShape="0" blurRad="12700" dist="50800" dir="2700000">
-              <a:srgbClr val="000000">
-                <a:alpha val="8000"/>
-              </a:srgbClr>
-            </a:outerShdw>
-          </a:effectLst>
-        </p:spPr>
-      </p:sp>
-      <p:pic>
-        <p:nvPicPr>
-          <p:cNvPr id="13" name="Image 2" descr="preencoded.png">    </p:cNvPr>
-          <p:cNvPicPr>
-            <a:picLocks noChangeAspect="1"/>
-          </p:cNvPicPr>
-          <p:nvPr/>
-        </p:nvPicPr>
-        <p:blipFill>
-          <a:blip r:embed="rId5">
-            <a:extLst>
-              <a:ext uri="{96DAC541-7B7A-43D3-8B79-37D633B846F1}">
-                <asvg:svgBlip xmlns:asvg="http://schemas.microsoft.com/office/drawing/2016/SVG/main" r:embed="rId6"/>
-              </a:ext>
-            </a:extLst>
-          </a:blip>
-          <a:stretch>
-            <a:fillRect/>
-          </a:stretch>
-        </p:blipFill>
-        <p:spPr>
-          <a:xfrm>
-            <a:off x="914400" y="4507992"/>
-            <a:ext cx="10241280" cy="1024128"/>
-          </a:xfrm>
-          <a:prstGeom prst="rect">
-            <a:avLst/>
-          </a:prstGeom>
-        </p:spPr>
-      </p:pic>
-      <p:sp>
-        <p:nvSpPr>
-          <p:cNvPr id="14" name="Shape 9"/>
-          <p:cNvSpPr/>
-          <p:nvPr/>
-        </p:nvSpPr>
-        <p:spPr>
-          <a:xfrm>
-            <a:off x="914400" y="4507992"/>
-            <a:ext cx="10241280" cy="1024128"/>
-          </a:xfrm>
-          <a:prstGeom prst="rect">
-            <a:avLst/>
-          </a:prstGeom>
-          <a:solidFill>
-            <a:srgbClr val="FFFFFF">
-              <a:alpha val="0"/>
-            </a:srgbClr>
-          </a:solidFill>
-          <a:ln w="12700">
-            <a:solidFill>
-              <a:srgbClr val="E5E7EB">
-                <a:alpha val="0"/>
-              </a:srgbClr>
-            </a:solidFill>
-            <a:prstDash val="solid"/>
-          </a:ln>
-          <a:effectLst>
-            <a:outerShdw sx="100000" sy="100000" kx="0" ky="0" algn="bl" rotWithShape="0" blurRad="12700" dist="50800" dir="2700000">
-              <a:srgbClr val="000000">
-                <a:alpha val="8000"/>
-              </a:srgbClr>
-            </a:outerShdw>
-          </a:effectLst>
-        </p:spPr>
-      </p:sp>
-      <p:sp>
-        <p:nvSpPr>
-          <p:cNvPr id="15" name="Shape 10"/>
-          <p:cNvSpPr/>
-          <p:nvPr/>
-        </p:nvSpPr>
-        <p:spPr>
-          <a:xfrm>
-            <a:off x="786384" y="1956816"/>
-            <a:ext cx="32004" cy="3483864"/>
-          </a:xfrm>
-          <a:prstGeom prst="rect">
-            <a:avLst/>
-          </a:prstGeom>
-          <a:solidFill>
-            <a:srgbClr val="38BDF8">
-              <a:alpha val="80000"/>
-            </a:srgbClr>
+        </p:spPr>
+      </p:sp>
+      <p:sp>
+        <p:nvSpPr>
+          <p:cNvPr id="10" name="Shape 8"/>
+          <p:cNvSpPr/>
+          <p:nvPr/>
+        </p:nvSpPr>
+        <p:spPr>
+          <a:xfrm>
+            <a:off x="4343400" y="1938528"/>
+            <a:ext cx="73152" cy="2514600"/>
+          </a:xfrm>
+          <a:prstGeom prst="rect">
+            <a:avLst/>
+          </a:prstGeom>
+          <a:solidFill>
+            <a:srgbClr val="38BDF8"/>
           </a:solidFill>
           <a:ln w="12700">
             <a:solidFill>
@@ -12564,14 +12454,14 @@
       </p:sp>
       <p:sp>
         <p:nvSpPr>
-          <p:cNvPr id="16" name="Shape 11"/>
-          <p:cNvSpPr/>
-          <p:nvPr/>
-        </p:nvSpPr>
-        <p:spPr>
-          <a:xfrm>
-            <a:off x="914400" y="1865376"/>
-            <a:ext cx="73152" cy="1024128"/>
+          <p:cNvPr id="11" name="Shape 9"/>
+          <p:cNvSpPr/>
+          <p:nvPr/>
+        </p:nvSpPr>
+        <p:spPr>
+          <a:xfrm>
+            <a:off x="7863840" y="1938528"/>
+            <a:ext cx="73152" cy="2514600"/>
           </a:xfrm>
           <a:prstGeom prst="rect">
             <a:avLst/>
@@ -12591,61 +12481,7 @@
       </p:sp>
       <p:sp>
         <p:nvSpPr>
-          <p:cNvPr id="17" name="Shape 12"/>
-          <p:cNvSpPr/>
-          <p:nvPr/>
-        </p:nvSpPr>
-        <p:spPr>
-          <a:xfrm>
-            <a:off x="914400" y="3191256"/>
-            <a:ext cx="73152" cy="1024128"/>
-          </a:xfrm>
-          <a:prstGeom prst="rect">
-            <a:avLst/>
-          </a:prstGeom>
-          <a:solidFill>
-            <a:srgbClr val="38BDF8"/>
-          </a:solidFill>
-          <a:ln w="12700">
-            <a:solidFill>
-              <a:srgbClr val="38BDF8">
-                <a:alpha val="0"/>
-              </a:srgbClr>
-            </a:solidFill>
-            <a:prstDash val="solid"/>
-          </a:ln>
-        </p:spPr>
-      </p:sp>
-      <p:sp>
-        <p:nvSpPr>
-          <p:cNvPr id="18" name="Shape 13"/>
-          <p:cNvSpPr/>
-          <p:nvPr/>
-        </p:nvSpPr>
-        <p:spPr>
-          <a:xfrm>
-            <a:off x="914400" y="4507992"/>
-            <a:ext cx="73152" cy="1024128"/>
-          </a:xfrm>
-          <a:prstGeom prst="rect">
-            <a:avLst/>
-          </a:prstGeom>
-          <a:solidFill>
-            <a:srgbClr val="F43F5E"/>
-          </a:solidFill>
-          <a:ln w="12700">
-            <a:solidFill>
-              <a:srgbClr val="F43F5E">
-                <a:alpha val="0"/>
-              </a:srgbClr>
-            </a:solidFill>
-            <a:prstDash val="solid"/>
-          </a:ln>
-        </p:spPr>
-      </p:sp>
-      <p:sp>
-        <p:nvSpPr>
-          <p:cNvPr id="19" name="mdpr:1-2-ea42c8:title:__title:1-2-ea42c8"/>
+          <p:cNvPr id="12" name="mdpr:1-2-ea42c8:title:__title:1-2-ea42c8"/>
           <p:cNvSpPr txBox="1"/>
           <p:nvPr/>
         </p:nvSpPr>
@@ -12687,14 +12523,14 @@
       </p:sp>
       <p:sp>
         <p:nvSpPr>
-          <p:cNvPr id="20" name="mdpr:1-2-ea42c8:item-1:block-27-chunk-1"/>
+          <p:cNvPr id="13" name="mdpr:1-2-ea42c8:item-1:block-27-chunk-1"/>
           <p:cNvSpPr txBox="1"/>
           <p:nvPr/>
         </p:nvSpPr>
         <p:spPr>
           <a:xfrm>
-            <a:off x="1133856" y="1957548"/>
-            <a:ext cx="9820656" cy="839785"/>
+            <a:off x="1042416" y="2103120"/>
+            <a:ext cx="2825496" cy="2185416"/>
           </a:xfrm>
           <a:prstGeom prst="rect">
             <a:avLst/>
@@ -12746,14 +12582,14 @@
       </p:sp>
       <p:sp>
         <p:nvSpPr>
-          <p:cNvPr id="21" name="mdpr:1-2-ea42c8:item-2:block-27-chunk-1"/>
+          <p:cNvPr id="14" name="mdpr:1-2-ea42c8:item-2:block-27-chunk-1"/>
           <p:cNvSpPr txBox="1"/>
           <p:nvPr/>
         </p:nvSpPr>
         <p:spPr>
           <a:xfrm>
-            <a:off x="1133856" y="3283428"/>
-            <a:ext cx="9820656" cy="839785"/>
+            <a:off x="4562856" y="2103120"/>
+            <a:ext cx="2825496" cy="2185416"/>
           </a:xfrm>
           <a:prstGeom prst="rect">
             <a:avLst/>
@@ -12805,14 +12641,14 @@
       </p:sp>
       <p:sp>
         <p:nvSpPr>
-          <p:cNvPr id="22" name="mdpr:1-2-ea42c8:item-3:block-27-chunk-1"/>
+          <p:cNvPr id="15" name="mdpr:1-2-ea42c8:item-3:block-27-chunk-1"/>
           <p:cNvSpPr txBox="1"/>
           <p:nvPr/>
         </p:nvSpPr>
         <p:spPr>
           <a:xfrm>
-            <a:off x="1133856" y="4600164"/>
-            <a:ext cx="9820656" cy="839785"/>
+            <a:off x="8083296" y="2103120"/>
+            <a:ext cx="2825496" cy="2185416"/>
           </a:xfrm>
           <a:prstGeom prst="rect">
             <a:avLst/>
@@ -13122,8 +12958,8 @@
         </p:nvSpPr>
         <p:spPr>
           <a:xfrm>
-            <a:off x="822960" y="1188720"/>
-            <a:ext cx="10515600" cy="45720"/>
+            <a:off x="822960" y="1737360"/>
+            <a:ext cx="73152" cy="841248"/>
           </a:xfrm>
           <a:prstGeom prst="rect">
             <a:avLst/>
@@ -13149,8 +12985,8 @@
         </p:nvSpPr>
         <p:spPr>
           <a:xfrm>
-            <a:off x="822960" y="6382512"/>
-            <a:ext cx="2011680" cy="45720"/>
+            <a:off x="822960" y="2779776"/>
+            <a:ext cx="73152" cy="841248"/>
           </a:xfrm>
           <a:prstGeom prst="rect">
             <a:avLst/>
@@ -13176,37 +13012,8 @@
         </p:nvSpPr>
         <p:spPr>
           <a:xfrm>
-            <a:off x="6080760" y="1389888"/>
-            <a:ext cx="22860" cy="4846320"/>
-          </a:xfrm>
-          <a:prstGeom prst="rect">
-            <a:avLst/>
-          </a:prstGeom>
-          <a:solidFill>
-            <a:srgbClr val="E5E7EB">
-              <a:alpha val="90000"/>
-            </a:srgbClr>
-          </a:solidFill>
-          <a:ln w="12700">
-            <a:solidFill>
-              <a:srgbClr val="E5E7EB">
-                <a:alpha val="0"/>
-              </a:srgbClr>
-            </a:solidFill>
-            <a:prstDash val="solid"/>
-          </a:ln>
-        </p:spPr>
-      </p:sp>
-      <p:sp>
-        <p:nvSpPr>
-          <p:cNvPr id="12" name="Shape 10"/>
-          <p:cNvSpPr/>
-          <p:nvPr/>
-        </p:nvSpPr>
-        <p:spPr>
-          <a:xfrm>
-            <a:off x="822960" y="1389888"/>
-            <a:ext cx="73152" cy="566928"/>
+            <a:off x="822960" y="3822192"/>
+            <a:ext cx="73152" cy="841248"/>
           </a:xfrm>
           <a:prstGeom prst="rect">
             <a:avLst/>
@@ -13226,14 +13033,14 @@
       </p:sp>
       <p:sp>
         <p:nvSpPr>
-          <p:cNvPr id="13" name="Shape 11"/>
-          <p:cNvSpPr/>
-          <p:nvPr/>
-        </p:nvSpPr>
-        <p:spPr>
-          <a:xfrm>
-            <a:off x="822960" y="2103120"/>
-            <a:ext cx="73152" cy="566928"/>
+          <p:cNvPr id="12" name="Shape 10"/>
+          <p:cNvSpPr/>
+          <p:nvPr/>
+        </p:nvSpPr>
+        <p:spPr>
+          <a:xfrm>
+            <a:off x="822960" y="4864608"/>
+            <a:ext cx="73152" cy="841248"/>
           </a:xfrm>
           <a:prstGeom prst="rect">
             <a:avLst/>
@@ -13253,14 +13060,14 @@
       </p:sp>
       <p:sp>
         <p:nvSpPr>
-          <p:cNvPr id="14" name="Shape 12"/>
-          <p:cNvSpPr/>
-          <p:nvPr/>
-        </p:nvSpPr>
-        <p:spPr>
-          <a:xfrm>
-            <a:off x="822960" y="2816352"/>
-            <a:ext cx="73152" cy="566928"/>
+          <p:cNvPr id="13" name="Shape 11"/>
+          <p:cNvSpPr/>
+          <p:nvPr/>
+        </p:nvSpPr>
+        <p:spPr>
+          <a:xfrm>
+            <a:off x="6272784" y="1737360"/>
+            <a:ext cx="73152" cy="841248"/>
           </a:xfrm>
           <a:prstGeom prst="rect">
             <a:avLst/>
@@ -13280,14 +13087,14 @@
       </p:sp>
       <p:sp>
         <p:nvSpPr>
-          <p:cNvPr id="15" name="Shape 13"/>
-          <p:cNvSpPr/>
-          <p:nvPr/>
-        </p:nvSpPr>
-        <p:spPr>
-          <a:xfrm>
-            <a:off x="822960" y="3529584"/>
-            <a:ext cx="73152" cy="566928"/>
+          <p:cNvPr id="14" name="Shape 12"/>
+          <p:cNvSpPr/>
+          <p:nvPr/>
+        </p:nvSpPr>
+        <p:spPr>
+          <a:xfrm>
+            <a:off x="6272784" y="2779776"/>
+            <a:ext cx="73152" cy="841248"/>
           </a:xfrm>
           <a:prstGeom prst="rect">
             <a:avLst/>
@@ -13307,14 +13114,14 @@
       </p:sp>
       <p:sp>
         <p:nvSpPr>
-          <p:cNvPr id="16" name="Shape 14"/>
-          <p:cNvSpPr/>
-          <p:nvPr/>
-        </p:nvSpPr>
-        <p:spPr>
-          <a:xfrm>
-            <a:off x="822960" y="4242816"/>
-            <a:ext cx="73152" cy="566928"/>
+          <p:cNvPr id="15" name="Shape 13"/>
+          <p:cNvSpPr/>
+          <p:nvPr/>
+        </p:nvSpPr>
+        <p:spPr>
+          <a:xfrm>
+            <a:off x="6272784" y="3822192"/>
+            <a:ext cx="73152" cy="841248"/>
           </a:xfrm>
           <a:prstGeom prst="rect">
             <a:avLst/>
@@ -13334,14 +13141,14 @@
       </p:sp>
       <p:sp>
         <p:nvSpPr>
-          <p:cNvPr id="17" name="Shape 15"/>
-          <p:cNvSpPr/>
-          <p:nvPr/>
-        </p:nvSpPr>
-        <p:spPr>
-          <a:xfrm>
-            <a:off x="822960" y="4956048"/>
-            <a:ext cx="73152" cy="566928"/>
+          <p:cNvPr id="16" name="Shape 14"/>
+          <p:cNvSpPr/>
+          <p:nvPr/>
+        </p:nvSpPr>
+        <p:spPr>
+          <a:xfrm>
+            <a:off x="6272784" y="4864608"/>
+            <a:ext cx="73152" cy="841248"/>
           </a:xfrm>
           <a:prstGeom prst="rect">
             <a:avLst/>
@@ -13361,223 +13168,7 @@
       </p:sp>
       <p:sp>
         <p:nvSpPr>
-          <p:cNvPr id="18" name="Shape 16"/>
-          <p:cNvSpPr/>
-          <p:nvPr/>
-        </p:nvSpPr>
-        <p:spPr>
-          <a:xfrm>
-            <a:off x="822960" y="5669280"/>
-            <a:ext cx="73152" cy="566928"/>
-          </a:xfrm>
-          <a:prstGeom prst="rect">
-            <a:avLst/>
-          </a:prstGeom>
-          <a:solidFill>
-            <a:srgbClr val="F43F5E"/>
-          </a:solidFill>
-          <a:ln w="12700">
-            <a:solidFill>
-              <a:srgbClr val="F43F5E">
-                <a:alpha val="0"/>
-              </a:srgbClr>
-            </a:solidFill>
-            <a:prstDash val="solid"/>
-          </a:ln>
-        </p:spPr>
-      </p:sp>
-      <p:sp>
-        <p:nvSpPr>
-          <p:cNvPr id="19" name="Shape 17"/>
-          <p:cNvSpPr/>
-          <p:nvPr/>
-        </p:nvSpPr>
-        <p:spPr>
-          <a:xfrm>
-            <a:off x="6272784" y="1389888"/>
-            <a:ext cx="73152" cy="566928"/>
-          </a:xfrm>
-          <a:prstGeom prst="rect">
-            <a:avLst/>
-          </a:prstGeom>
-          <a:solidFill>
-            <a:srgbClr val="38BDF8"/>
-          </a:solidFill>
-          <a:ln w="12700">
-            <a:solidFill>
-              <a:srgbClr val="38BDF8">
-                <a:alpha val="0"/>
-              </a:srgbClr>
-            </a:solidFill>
-            <a:prstDash val="solid"/>
-          </a:ln>
-        </p:spPr>
-      </p:sp>
-      <p:sp>
-        <p:nvSpPr>
-          <p:cNvPr id="20" name="Shape 18"/>
-          <p:cNvSpPr/>
-          <p:nvPr/>
-        </p:nvSpPr>
-        <p:spPr>
-          <a:xfrm>
-            <a:off x="6272784" y="2103120"/>
-            <a:ext cx="73152" cy="566928"/>
-          </a:xfrm>
-          <a:prstGeom prst="rect">
-            <a:avLst/>
-          </a:prstGeom>
-          <a:solidFill>
-            <a:srgbClr val="F43F5E"/>
-          </a:solidFill>
-          <a:ln w="12700">
-            <a:solidFill>
-              <a:srgbClr val="F43F5E">
-                <a:alpha val="0"/>
-              </a:srgbClr>
-            </a:solidFill>
-            <a:prstDash val="solid"/>
-          </a:ln>
-        </p:spPr>
-      </p:sp>
-      <p:sp>
-        <p:nvSpPr>
-          <p:cNvPr id="21" name="Shape 19"/>
-          <p:cNvSpPr/>
-          <p:nvPr/>
-        </p:nvSpPr>
-        <p:spPr>
-          <a:xfrm>
-            <a:off x="6272784" y="2816352"/>
-            <a:ext cx="73152" cy="566928"/>
-          </a:xfrm>
-          <a:prstGeom prst="rect">
-            <a:avLst/>
-          </a:prstGeom>
-          <a:solidFill>
-            <a:srgbClr val="38BDF8"/>
-          </a:solidFill>
-          <a:ln w="12700">
-            <a:solidFill>
-              <a:srgbClr val="38BDF8">
-                <a:alpha val="0"/>
-              </a:srgbClr>
-            </a:solidFill>
-            <a:prstDash val="solid"/>
-          </a:ln>
-        </p:spPr>
-      </p:sp>
-      <p:sp>
-        <p:nvSpPr>
-          <p:cNvPr id="22" name="Shape 20"/>
-          <p:cNvSpPr/>
-          <p:nvPr/>
-        </p:nvSpPr>
-        <p:spPr>
-          <a:xfrm>
-            <a:off x="6272784" y="3529584"/>
-            <a:ext cx="73152" cy="566928"/>
-          </a:xfrm>
-          <a:prstGeom prst="rect">
-            <a:avLst/>
-          </a:prstGeom>
-          <a:solidFill>
-            <a:srgbClr val="F43F5E"/>
-          </a:solidFill>
-          <a:ln w="12700">
-            <a:solidFill>
-              <a:srgbClr val="F43F5E">
-                <a:alpha val="0"/>
-              </a:srgbClr>
-            </a:solidFill>
-            <a:prstDash val="solid"/>
-          </a:ln>
-        </p:spPr>
-      </p:sp>
-      <p:sp>
-        <p:nvSpPr>
-          <p:cNvPr id="23" name="Shape 21"/>
-          <p:cNvSpPr/>
-          <p:nvPr/>
-        </p:nvSpPr>
-        <p:spPr>
-          <a:xfrm>
-            <a:off x="6272784" y="4242816"/>
-            <a:ext cx="73152" cy="566928"/>
-          </a:xfrm>
-          <a:prstGeom prst="rect">
-            <a:avLst/>
-          </a:prstGeom>
-          <a:solidFill>
-            <a:srgbClr val="38BDF8"/>
-          </a:solidFill>
-          <a:ln w="12700">
-            <a:solidFill>
-              <a:srgbClr val="38BDF8">
-                <a:alpha val="0"/>
-              </a:srgbClr>
-            </a:solidFill>
-            <a:prstDash val="solid"/>
-          </a:ln>
-        </p:spPr>
-      </p:sp>
-      <p:sp>
-        <p:nvSpPr>
-          <p:cNvPr id="24" name="Shape 22"/>
-          <p:cNvSpPr/>
-          <p:nvPr/>
-        </p:nvSpPr>
-        <p:spPr>
-          <a:xfrm>
-            <a:off x="6272784" y="4956048"/>
-            <a:ext cx="73152" cy="566928"/>
-          </a:xfrm>
-          <a:prstGeom prst="rect">
-            <a:avLst/>
-          </a:prstGeom>
-          <a:solidFill>
-            <a:srgbClr val="F43F5E"/>
-          </a:solidFill>
-          <a:ln w="12700">
-            <a:solidFill>
-              <a:srgbClr val="F43F5E">
-                <a:alpha val="0"/>
-              </a:srgbClr>
-            </a:solidFill>
-            <a:prstDash val="solid"/>
-          </a:ln>
-        </p:spPr>
-      </p:sp>
-      <p:sp>
-        <p:nvSpPr>
-          <p:cNvPr id="25" name="Shape 23"/>
-          <p:cNvSpPr/>
-          <p:nvPr/>
-        </p:nvSpPr>
-        <p:spPr>
-          <a:xfrm>
-            <a:off x="6272784" y="5669280"/>
-            <a:ext cx="73152" cy="566928"/>
-          </a:xfrm>
-          <a:prstGeom prst="rect">
-            <a:avLst/>
-          </a:prstGeom>
-          <a:solidFill>
-            <a:srgbClr val="38BDF8"/>
-          </a:solidFill>
-          <a:ln w="12700">
-            <a:solidFill>
-              <a:srgbClr val="38BDF8">
-                <a:alpha val="0"/>
-              </a:srgbClr>
-            </a:solidFill>
-            <a:prstDash val="solid"/>
-          </a:ln>
-        </p:spPr>
-      </p:sp>
-      <p:sp>
-        <p:nvSpPr>
-          <p:cNvPr id="26" name="mdpr:1-2-0772f8:title:__title:1-2-0772f8"/>
+          <p:cNvPr id="17" name="mdpr:1-2-0772f8:title:__title:1-2-0772f8"/>
           <p:cNvSpPr txBox="1"/>
           <p:nvPr/>
         </p:nvSpPr>
@@ -13619,14 +13210,14 @@
       </p:sp>
       <p:sp>
         <p:nvSpPr>
-          <p:cNvPr id="27" name="mdpr:1-2-0772f8:toc-item-1:toc-item-1"/>
+          <p:cNvPr id="18" name="mdpr:1-2-0772f8:toc-item-1:toc-item-1"/>
           <p:cNvSpPr txBox="1"/>
           <p:nvPr/>
         </p:nvSpPr>
         <p:spPr>
           <a:xfrm>
-            <a:off x="1042416" y="1481328"/>
-            <a:ext cx="4645152" cy="384048"/>
+            <a:off x="1042416" y="1828800"/>
+            <a:ext cx="4645152" cy="658368"/>
           </a:xfrm>
           <a:prstGeom prst="rect">
             <a:avLst/>
@@ -13661,14 +13252,14 @@
       </p:sp>
       <p:sp>
         <p:nvSpPr>
-          <p:cNvPr id="28" name="mdpr:1-2-0772f8:toc-item-2:toc-item-2"/>
+          <p:cNvPr id="19" name="mdpr:1-2-0772f8:toc-item-2:toc-item-2"/>
           <p:cNvSpPr txBox="1"/>
           <p:nvPr/>
         </p:nvSpPr>
         <p:spPr>
           <a:xfrm>
-            <a:off x="1042416" y="2194560"/>
-            <a:ext cx="4645152" cy="384048"/>
+            <a:off x="1042416" y="2871216"/>
+            <a:ext cx="4645152" cy="658368"/>
           </a:xfrm>
           <a:prstGeom prst="rect">
             <a:avLst/>
@@ -13703,14 +13294,14 @@
       </p:sp>
       <p:sp>
         <p:nvSpPr>
-          <p:cNvPr id="29" name="mdpr:1-2-0772f8:toc-item-3:toc-item-3"/>
+          <p:cNvPr id="20" name="mdpr:1-2-0772f8:toc-item-3:toc-item-3"/>
           <p:cNvSpPr txBox="1"/>
           <p:nvPr/>
         </p:nvSpPr>
         <p:spPr>
           <a:xfrm>
-            <a:off x="1042416" y="2907792"/>
-            <a:ext cx="4645152" cy="384048"/>
+            <a:off x="1042416" y="3913632"/>
+            <a:ext cx="4645152" cy="658368"/>
           </a:xfrm>
           <a:prstGeom prst="rect">
             <a:avLst/>
@@ -13745,14 +13336,14 @@
       </p:sp>
       <p:sp>
         <p:nvSpPr>
-          <p:cNvPr id="30" name="mdpr:1-2-0772f8:toc-item-4:toc-item-4"/>
+          <p:cNvPr id="21" name="mdpr:1-2-0772f8:toc-item-4:toc-item-4"/>
           <p:cNvSpPr txBox="1"/>
           <p:nvPr/>
         </p:nvSpPr>
         <p:spPr>
           <a:xfrm>
-            <a:off x="1042416" y="3621024"/>
-            <a:ext cx="4645152" cy="384048"/>
+            <a:off x="1042416" y="4956048"/>
+            <a:ext cx="4645152" cy="658368"/>
           </a:xfrm>
           <a:prstGeom prst="rect">
             <a:avLst/>
@@ -13787,14 +13378,14 @@
       </p:sp>
       <p:sp>
         <p:nvSpPr>
-          <p:cNvPr id="31" name="mdpr:1-2-0772f8:toc-item-5:toc-item-5"/>
+          <p:cNvPr id="22" name="mdpr:1-2-0772f8:toc-item-5:toc-item-5"/>
           <p:cNvSpPr txBox="1"/>
           <p:nvPr/>
         </p:nvSpPr>
         <p:spPr>
           <a:xfrm>
-            <a:off x="1042416" y="4334256"/>
-            <a:ext cx="4645152" cy="384048"/>
+            <a:off x="6492240" y="1828800"/>
+            <a:ext cx="4645152" cy="658368"/>
           </a:xfrm>
           <a:prstGeom prst="rect">
             <a:avLst/>
@@ -13829,14 +13420,14 @@
       </p:sp>
       <p:sp>
         <p:nvSpPr>
-          <p:cNvPr id="32" name="mdpr:1-2-0772f8:toc-item-6:toc-item-6"/>
+          <p:cNvPr id="23" name="mdpr:1-2-0772f8:toc-item-6:toc-item-6"/>
           <p:cNvSpPr txBox="1"/>
           <p:nvPr/>
         </p:nvSpPr>
         <p:spPr>
           <a:xfrm>
-            <a:off x="1042416" y="5047488"/>
-            <a:ext cx="4645152" cy="384048"/>
+            <a:off x="6492240" y="2871216"/>
+            <a:ext cx="4645152" cy="658368"/>
           </a:xfrm>
           <a:prstGeom prst="rect">
             <a:avLst/>
@@ -13871,14 +13462,14 @@
       </p:sp>
       <p:sp>
         <p:nvSpPr>
-          <p:cNvPr id="33" name="mdpr:1-2-0772f8:toc-item-7:toc-item-7"/>
+          <p:cNvPr id="24" name="mdpr:1-2-0772f8:toc-item-7:toc-item-7"/>
           <p:cNvSpPr txBox="1"/>
           <p:nvPr/>
         </p:nvSpPr>
         <p:spPr>
           <a:xfrm>
-            <a:off x="1042416" y="5760720"/>
-            <a:ext cx="4645152" cy="384048"/>
+            <a:off x="6492240" y="3913632"/>
+            <a:ext cx="4645152" cy="658368"/>
           </a:xfrm>
           <a:prstGeom prst="rect">
             <a:avLst/>
@@ -13913,14 +13504,14 @@
       </p:sp>
       <p:sp>
         <p:nvSpPr>
-          <p:cNvPr id="34" name="mdpr:1-2-0772f8:toc-item-8:toc-item-8"/>
+          <p:cNvPr id="25" name="mdpr:1-2-0772f8:toc-item-8:toc-item-8"/>
           <p:cNvSpPr txBox="1"/>
           <p:nvPr/>
         </p:nvSpPr>
         <p:spPr>
           <a:xfrm>
-            <a:off x="6492240" y="1481328"/>
-            <a:ext cx="4645152" cy="384048"/>
+            <a:off x="6492240" y="4956048"/>
+            <a:ext cx="4645152" cy="658368"/>
           </a:xfrm>
           <a:prstGeom prst="rect">
             <a:avLst/>
@@ -13948,258 +13539,6 @@
                 <a:cs typeface="Pretendard" pitchFamily="34" charset="-120"/>
               </a:rPr>
               <a:t>08  Chart and Table Pair</a:t>
-            </a:r>
-            <a:endParaRPr lang="en-US" sz="1800" dirty="0"/>
-          </a:p>
-        </p:txBody>
-      </p:sp>
-      <p:sp>
-        <p:nvSpPr>
-          <p:cNvPr id="35" name="mdpr:1-2-0772f8:toc-item-9:toc-item-9"/>
-          <p:cNvSpPr txBox="1"/>
-          <p:nvPr/>
-        </p:nvSpPr>
-        <p:spPr>
-          <a:xfrm>
-            <a:off x="6492240" y="2194560"/>
-            <a:ext cx="4645152" cy="384048"/>
-          </a:xfrm>
-          <a:prstGeom prst="rect">
-            <a:avLst/>
-          </a:prstGeom>
-          <a:noFill/>
-          <a:ln/>
-        </p:spPr>
-        <p:txBody>
-          <a:bodyPr wrap="square" lIns="0" tIns="25400" rIns="25400" bIns="0" rtlCol="0" anchor="ctr"/>
-          <a:lstStyle/>
-          <a:p>
-            <a:pPr algn="ctr" indent="0" marL="0">
-              <a:lnSpc>
-                <a:spcPct val="120000"/>
-              </a:lnSpc>
-              <a:buNone/>
-            </a:pPr>
-            <a:r>
-              <a:rPr lang="en-US" sz="1800" dirty="0">
-                <a:solidFill>
-                  <a:srgbClr val="111111"/>
-                </a:solidFill>
-                <a:latin typeface="Pretendard" pitchFamily="34" charset="0"/>
-                <a:ea typeface="Pretendard" pitchFamily="34" charset="-122"/>
-                <a:cs typeface="Pretendard" pitchFamily="34" charset="-120"/>
-              </a:rPr>
-              <a:t>09  Editable Proof Objects</a:t>
-            </a:r>
-            <a:endParaRPr lang="en-US" sz="1800" dirty="0"/>
-          </a:p>
-        </p:txBody>
-      </p:sp>
-      <p:sp>
-        <p:nvSpPr>
-          <p:cNvPr id="36" name="mdpr:1-2-0772f8:toc-item-10:toc-item-10"/>
-          <p:cNvSpPr txBox="1"/>
-          <p:nvPr/>
-        </p:nvSpPr>
-        <p:spPr>
-          <a:xfrm>
-            <a:off x="6492240" y="2907792"/>
-            <a:ext cx="4645152" cy="384048"/>
-          </a:xfrm>
-          <a:prstGeom prst="rect">
-            <a:avLst/>
-          </a:prstGeom>
-          <a:noFill/>
-          <a:ln/>
-        </p:spPr>
-        <p:txBody>
-          <a:bodyPr wrap="square" lIns="0" tIns="25400" rIns="25400" bIns="0" rtlCol="0" anchor="ctr"/>
-          <a:lstStyle/>
-          <a:p>
-            <a:pPr algn="ctr" indent="0" marL="0">
-              <a:lnSpc>
-                <a:spcPct val="120000"/>
-              </a:lnSpc>
-              <a:buNone/>
-            </a:pPr>
-            <a:r>
-              <a:rPr lang="en-US" sz="1800" dirty="0">
-                <a:solidFill>
-                  <a:srgbClr val="111111"/>
-                </a:solidFill>
-                <a:latin typeface="Pretendard" pitchFamily="34" charset="0"/>
-                <a:ea typeface="Pretendard" pitchFamily="34" charset="-122"/>
-                <a:cs typeface="Pretendard" pitchFamily="34" charset="-120"/>
-              </a:rPr>
-              <a:t>10  Object Shape Grammar</a:t>
-            </a:r>
-            <a:endParaRPr lang="en-US" sz="1800" dirty="0"/>
-          </a:p>
-        </p:txBody>
-      </p:sp>
-      <p:sp>
-        <p:nvSpPr>
-          <p:cNvPr id="37" name="mdpr:1-2-0772f8:toc-item-11:toc-item-11"/>
-          <p:cNvSpPr txBox="1"/>
-          <p:nvPr/>
-        </p:nvSpPr>
-        <p:spPr>
-          <a:xfrm>
-            <a:off x="6492240" y="3621024"/>
-            <a:ext cx="4645152" cy="384048"/>
-          </a:xfrm>
-          <a:prstGeom prst="rect">
-            <a:avLst/>
-          </a:prstGeom>
-          <a:noFill/>
-          <a:ln/>
-        </p:spPr>
-        <p:txBody>
-          <a:bodyPr wrap="square" lIns="0" tIns="25400" rIns="25400" bIns="0" rtlCol="0" anchor="ctr"/>
-          <a:lstStyle/>
-          <a:p>
-            <a:pPr algn="ctr" indent="0" marL="0">
-              <a:lnSpc>
-                <a:spcPct val="120000"/>
-              </a:lnSpc>
-              <a:buNone/>
-            </a:pPr>
-            <a:r>
-              <a:rPr lang="en-US" sz="1800" dirty="0">
-                <a:solidFill>
-                  <a:srgbClr val="111111"/>
-                </a:solidFill>
-                <a:latin typeface="Pretendard" pitchFamily="34" charset="0"/>
-                <a:ea typeface="Pretendard" pitchFamily="34" charset="-122"/>
-                <a:cs typeface="Pretendard" pitchFamily="34" charset="-120"/>
-              </a:rPr>
-              <a:t>11  Icon and Text Aside</a:t>
-            </a:r>
-            <a:endParaRPr lang="en-US" sz="1800" dirty="0"/>
-          </a:p>
-        </p:txBody>
-      </p:sp>
-      <p:sp>
-        <p:nvSpPr>
-          <p:cNvPr id="38" name="mdpr:1-2-0772f8:toc-item-12:toc-item-12"/>
-          <p:cNvSpPr txBox="1"/>
-          <p:nvPr/>
-        </p:nvSpPr>
-        <p:spPr>
-          <a:xfrm>
-            <a:off x="6492240" y="4334256"/>
-            <a:ext cx="4645152" cy="384048"/>
-          </a:xfrm>
-          <a:prstGeom prst="rect">
-            <a:avLst/>
-          </a:prstGeom>
-          <a:noFill/>
-          <a:ln/>
-        </p:spPr>
-        <p:txBody>
-          <a:bodyPr wrap="square" lIns="0" tIns="25400" rIns="25400" bIns="0" rtlCol="0" anchor="ctr"/>
-          <a:lstStyle/>
-          <a:p>
-            <a:pPr algn="ctr" indent="0" marL="0">
-              <a:lnSpc>
-                <a:spcPct val="120000"/>
-              </a:lnSpc>
-              <a:buNone/>
-            </a:pPr>
-            <a:r>
-              <a:rPr lang="en-US" sz="1800" dirty="0">
-                <a:solidFill>
-                  <a:srgbClr val="111111"/>
-                </a:solidFill>
-                <a:latin typeface="Pretendard" pitchFamily="34" charset="0"/>
-                <a:ea typeface="Pretendard" pitchFamily="34" charset="-122"/>
-                <a:cs typeface="Pretendard" pitchFamily="34" charset="-120"/>
-              </a:rPr>
-              <a:t>12  Overflow Guard</a:t>
-            </a:r>
-            <a:endParaRPr lang="en-US" sz="1800" dirty="0"/>
-          </a:p>
-        </p:txBody>
-      </p:sp>
-      <p:sp>
-        <p:nvSpPr>
-          <p:cNvPr id="39" name="mdpr:1-2-0772f8:toc-item-13:toc-item-13"/>
-          <p:cNvSpPr txBox="1"/>
-          <p:nvPr/>
-        </p:nvSpPr>
-        <p:spPr>
-          <a:xfrm>
-            <a:off x="6492240" y="5047488"/>
-            <a:ext cx="4645152" cy="384048"/>
-          </a:xfrm>
-          <a:prstGeom prst="rect">
-            <a:avLst/>
-          </a:prstGeom>
-          <a:noFill/>
-          <a:ln/>
-        </p:spPr>
-        <p:txBody>
-          <a:bodyPr wrap="square" lIns="0" tIns="25400" rIns="25400" bIns="0" rtlCol="0" anchor="ctr"/>
-          <a:lstStyle/>
-          <a:p>
-            <a:pPr algn="ctr" indent="0" marL="0">
-              <a:lnSpc>
-                <a:spcPct val="120000"/>
-              </a:lnSpc>
-              <a:buNone/>
-            </a:pPr>
-            <a:r>
-              <a:rPr lang="en-US" sz="1800" dirty="0">
-                <a:solidFill>
-                  <a:srgbClr val="111111"/>
-                </a:solidFill>
-                <a:latin typeface="Pretendard" pitchFamily="34" charset="0"/>
-                <a:ea typeface="Pretendard" pitchFamily="34" charset="-122"/>
-                <a:cs typeface="Pretendard" pitchFamily="34" charset="-120"/>
-              </a:rPr>
-              <a:t>13  Image Safe Frame</a:t>
-            </a:r>
-            <a:endParaRPr lang="en-US" sz="1800" dirty="0"/>
-          </a:p>
-        </p:txBody>
-      </p:sp>
-      <p:sp>
-        <p:nvSpPr>
-          <p:cNvPr id="40" name="mdpr:1-2-0772f8:toc-item-14:toc-item-14"/>
-          <p:cNvSpPr txBox="1"/>
-          <p:nvPr/>
-        </p:nvSpPr>
-        <p:spPr>
-          <a:xfrm>
-            <a:off x="6492240" y="5760720"/>
-            <a:ext cx="4645152" cy="384048"/>
-          </a:xfrm>
-          <a:prstGeom prst="rect">
-            <a:avLst/>
-          </a:prstGeom>
-          <a:noFill/>
-          <a:ln/>
-        </p:spPr>
-        <p:txBody>
-          <a:bodyPr wrap="square" lIns="0" tIns="25400" rIns="25400" bIns="0" rtlCol="0" anchor="ctr"/>
-          <a:lstStyle/>
-          <a:p>
-            <a:pPr algn="ctr" indent="0" marL="0">
-              <a:lnSpc>
-                <a:spcPct val="120000"/>
-              </a:lnSpc>
-              <a:buNone/>
-            </a:pPr>
-            <a:r>
-              <a:rPr lang="en-US" sz="1800" dirty="0">
-                <a:solidFill>
-                  <a:srgbClr val="111111"/>
-                </a:solidFill>
-                <a:latin typeface="Pretendard" pitchFamily="34" charset="0"/>
-                <a:ea typeface="Pretendard" pitchFamily="34" charset="-122"/>
-                <a:cs typeface="Pretendard" pitchFamily="34" charset="-120"/>
-              </a:rPr>
-              <a:t>14  Mixed Object Packing</a:t>
             </a:r>
             <a:endParaRPr lang="en-US" sz="1800" dirty="0"/>
           </a:p>
@@ -14465,8 +13804,8 @@
         </p:nvSpPr>
         <p:spPr>
           <a:xfrm>
-            <a:off x="822960" y="1554480"/>
-            <a:ext cx="4937760" cy="73152"/>
+            <a:off x="914400" y="1463040"/>
+            <a:ext cx="10241280" cy="73152"/>
           </a:xfrm>
           <a:prstGeom prst="rect">
             <a:avLst/>
@@ -14486,34 +13825,7 @@
       </p:sp>
       <p:sp>
         <p:nvSpPr>
-          <p:cNvPr id="10" name="Shape 8"/>
-          <p:cNvSpPr/>
-          <p:nvPr/>
-        </p:nvSpPr>
-        <p:spPr>
-          <a:xfrm>
-            <a:off x="6400800" y="1554480"/>
-            <a:ext cx="4937760" cy="73152"/>
-          </a:xfrm>
-          <a:prstGeom prst="rect">
-            <a:avLst/>
-          </a:prstGeom>
-          <a:solidFill>
-            <a:srgbClr val="F43F5E"/>
-          </a:solidFill>
-          <a:ln w="12700">
-            <a:solidFill>
-              <a:srgbClr val="F43F5E">
-                <a:alpha val="0"/>
-              </a:srgbClr>
-            </a:solidFill>
-            <a:prstDash val="solid"/>
-          </a:ln>
-        </p:spPr>
-      </p:sp>
-      <p:sp>
-        <p:nvSpPr>
-          <p:cNvPr id="11" name="mdpr:2-2-4f71ba:title:__title:2-2-4f71ba"/>
+          <p:cNvPr id="10" name="mdpr:2-2-4f71ba:title:__title:2-2-4f71ba"/>
           <p:cNvSpPr txBox="1"/>
           <p:nvPr/>
         </p:nvSpPr>
@@ -14547,7 +13859,24 @@
                 <a:ea typeface="Pretendard" pitchFamily="34" charset="-122"/>
                 <a:cs typeface="Pretendard" pitchFamily="34" charset="-120"/>
               </a:rPr>
-              <a:t>Object Shape Grammar (Cont. 2/2)</a:t>
+              <a:t>Object Shape Grammar</a:t>
+            </a:r>
+            <a:pPr algn="ctr" indent="0" marL="0">
+              <a:lnSpc>
+                <a:spcPct val="120000"/>
+              </a:lnSpc>
+              <a:buNone/>
+            </a:pPr>
+            <a:r>
+              <a:rPr lang="en-US" sz="2000" dirty="0">
+                <a:solidFill>
+                  <a:srgbClr val="8F8F8F"/>
+                </a:solidFill>
+                <a:latin typeface="Pretendard" pitchFamily="34" charset="0"/>
+                <a:ea typeface="Pretendard" pitchFamily="34" charset="-122"/>
+                <a:cs typeface="Pretendard" pitchFamily="34" charset="-120"/>
+              </a:rPr>
+              <a:t> (Cont. 2/2)</a:t>
             </a:r>
             <a:endParaRPr lang="en-US" sz="3400" dirty="0"/>
           </a:p>
@@ -14555,14 +13884,14 @@
       </p:sp>
       <p:sp>
         <p:nvSpPr>
-          <p:cNvPr id="12" name="mdpr:2-2-4f71ba:left:block-27-chunk-2"/>
+          <p:cNvPr id="11" name="mdpr:2-2-4f71ba:body:block-27-chunk-2"/>
           <p:cNvSpPr txBox="1"/>
           <p:nvPr/>
         </p:nvSpPr>
         <p:spPr>
           <a:xfrm>
-            <a:off x="896112" y="1664208"/>
-            <a:ext cx="4791456" cy="4169664"/>
+            <a:off x="987552" y="1572768"/>
+            <a:ext cx="10094976" cy="4261104"/>
           </a:xfrm>
           <a:prstGeom prst="rect">
             <a:avLst/>
@@ -14610,28 +13939,6 @@
             </a:r>
             <a:endParaRPr lang="en-US" sz="2200" dirty="0"/>
           </a:p>
-        </p:txBody>
-      </p:sp>
-      <p:sp>
-        <p:nvSpPr>
-          <p:cNvPr id="13" name="mdpr:2-2-4f71ba:right:block-27-chunk-2"/>
-          <p:cNvSpPr txBox="1"/>
-          <p:nvPr/>
-        </p:nvSpPr>
-        <p:spPr>
-          <a:xfrm>
-            <a:off x="6473952" y="1664208"/>
-            <a:ext cx="4791456" cy="4169664"/>
-          </a:xfrm>
-          <a:prstGeom prst="rect">
-            <a:avLst/>
-          </a:prstGeom>
-          <a:noFill/>
-          <a:ln/>
-        </p:spPr>
-        <p:txBody>
-          <a:bodyPr wrap="square" lIns="0" tIns="25400" rIns="25400" bIns="0" rtlCol="0" anchor="t"/>
-          <a:lstStyle/>
           <a:p>
             <a:pPr algn="l" indent="0" marL="0">
               <a:lnSpc>
@@ -14650,6 +13957,9 @@
               </a:rPr>
               <a:t>- Rounded panel</a:t>
             </a:r>
+            <a:endParaRPr lang="en-US" sz="2200" dirty="0"/>
+          </a:p>
+          <a:p>
             <a:pPr algn="l" indent="0" marL="0">
               <a:lnSpc>
                 <a:spcPct val="120000"/>
@@ -18389,222 +17699,49 @@
           </a:ln>
         </p:spPr>
       </p:sp>
-      <p:pic>
-        <p:nvPicPr>
-          <p:cNvPr id="9" name="Image 0" descr="preencoded.png">    </p:cNvPr>
-          <p:cNvPicPr>
-            <a:picLocks noChangeAspect="1"/>
-          </p:cNvPicPr>
-          <p:nvPr/>
-        </p:nvPicPr>
-        <p:blipFill>
-          <a:blip r:embed="rId1">
-            <a:extLst>
-              <a:ext uri="{96DAC541-7B7A-43D3-8B79-37D633B846F1}">
-                <asvg:svgBlip xmlns:asvg="http://schemas.microsoft.com/office/drawing/2016/SVG/main" r:embed="rId2"/>
-              </a:ext>
-            </a:extLst>
-          </a:blip>
-          <a:stretch>
-            <a:fillRect/>
-          </a:stretch>
-        </p:blipFill>
-        <p:spPr>
-          <a:xfrm>
-            <a:off x="914400" y="1865376"/>
-            <a:ext cx="10241280" cy="1024128"/>
-          </a:xfrm>
-          <a:prstGeom prst="rect">
-            <a:avLst/>
-          </a:prstGeom>
-        </p:spPr>
-      </p:pic>
-      <p:sp>
-        <p:nvSpPr>
-          <p:cNvPr id="10" name="Shape 7"/>
-          <p:cNvSpPr/>
-          <p:nvPr/>
-        </p:nvSpPr>
-        <p:spPr>
-          <a:xfrm>
-            <a:off x="914400" y="1865376"/>
-            <a:ext cx="10241280" cy="1024128"/>
-          </a:xfrm>
-          <a:prstGeom prst="rect">
-            <a:avLst/>
-          </a:prstGeom>
-          <a:solidFill>
-            <a:srgbClr val="FFFFFF">
-              <a:alpha val="0"/>
-            </a:srgbClr>
-          </a:solidFill>
-          <a:ln w="12700">
-            <a:solidFill>
-              <a:srgbClr val="E5E7EB">
+      <p:sp>
+        <p:nvSpPr>
+          <p:cNvPr id="9" name="Shape 7"/>
+          <p:cNvSpPr/>
+          <p:nvPr/>
+        </p:nvSpPr>
+        <p:spPr>
+          <a:xfrm>
+            <a:off x="822960" y="1938528"/>
+            <a:ext cx="73152" cy="2514600"/>
+          </a:xfrm>
+          <a:prstGeom prst="rect">
+            <a:avLst/>
+          </a:prstGeom>
+          <a:solidFill>
+            <a:srgbClr val="F43F5E"/>
+          </a:solidFill>
+          <a:ln w="12700">
+            <a:solidFill>
+              <a:srgbClr val="F43F5E">
                 <a:alpha val="0"/>
               </a:srgbClr>
             </a:solidFill>
             <a:prstDash val="solid"/>
           </a:ln>
-          <a:effectLst>
-            <a:outerShdw sx="100000" sy="100000" kx="0" ky="0" algn="bl" rotWithShape="0" blurRad="12700" dist="50800" dir="2700000">
-              <a:srgbClr val="000000">
-                <a:alpha val="8000"/>
-              </a:srgbClr>
-            </a:outerShdw>
-          </a:effectLst>
-        </p:spPr>
-      </p:sp>
-      <p:pic>
-        <p:nvPicPr>
-          <p:cNvPr id="11" name="Image 1" descr="preencoded.png">    </p:cNvPr>
-          <p:cNvPicPr>
-            <a:picLocks noChangeAspect="1"/>
-          </p:cNvPicPr>
-          <p:nvPr/>
-        </p:nvPicPr>
-        <p:blipFill>
-          <a:blip r:embed="rId3">
-            <a:extLst>
-              <a:ext uri="{96DAC541-7B7A-43D3-8B79-37D633B846F1}">
-                <asvg:svgBlip xmlns:asvg="http://schemas.microsoft.com/office/drawing/2016/SVG/main" r:embed="rId4"/>
-              </a:ext>
-            </a:extLst>
-          </a:blip>
-          <a:stretch>
-            <a:fillRect/>
-          </a:stretch>
-        </p:blipFill>
-        <p:spPr>
-          <a:xfrm>
-            <a:off x="914400" y="3191256"/>
-            <a:ext cx="10241280" cy="1024128"/>
-          </a:xfrm>
-          <a:prstGeom prst="rect">
-            <a:avLst/>
-          </a:prstGeom>
-        </p:spPr>
-      </p:pic>
-      <p:sp>
-        <p:nvSpPr>
-          <p:cNvPr id="12" name="Shape 8"/>
-          <p:cNvSpPr/>
-          <p:nvPr/>
-        </p:nvSpPr>
-        <p:spPr>
-          <a:xfrm>
-            <a:off x="914400" y="3191256"/>
-            <a:ext cx="10241280" cy="1024128"/>
-          </a:xfrm>
-          <a:prstGeom prst="rect">
-            <a:avLst/>
-          </a:prstGeom>
-          <a:solidFill>
-            <a:srgbClr val="FFFFFF">
-              <a:alpha val="0"/>
-            </a:srgbClr>
-          </a:solidFill>
-          <a:ln w="12700">
-            <a:solidFill>
-              <a:srgbClr val="E5E7EB">
-                <a:alpha val="0"/>
-              </a:srgbClr>
-            </a:solidFill>
-            <a:prstDash val="solid"/>
-          </a:ln>
-          <a:effectLst>
-            <a:outerShdw sx="100000" sy="100000" kx="0" ky="0" algn="bl" rotWithShape="0" blurRad="12700" dist="50800" dir="2700000">
-              <a:srgbClr val="000000">
-                <a:alpha val="8000"/>
-              </a:srgbClr>
-            </a:outerShdw>
-          </a:effectLst>
-        </p:spPr>
-      </p:sp>
-      <p:pic>
-        <p:nvPicPr>
-          <p:cNvPr id="13" name="Image 2" descr="preencoded.png">    </p:cNvPr>
-          <p:cNvPicPr>
-            <a:picLocks noChangeAspect="1"/>
-          </p:cNvPicPr>
-          <p:nvPr/>
-        </p:nvPicPr>
-        <p:blipFill>
-          <a:blip r:embed="rId5">
-            <a:extLst>
-              <a:ext uri="{96DAC541-7B7A-43D3-8B79-37D633B846F1}">
-                <asvg:svgBlip xmlns:asvg="http://schemas.microsoft.com/office/drawing/2016/SVG/main" r:embed="rId6"/>
-              </a:ext>
-            </a:extLst>
-          </a:blip>
-          <a:stretch>
-            <a:fillRect/>
-          </a:stretch>
-        </p:blipFill>
-        <p:spPr>
-          <a:xfrm>
-            <a:off x="914400" y="4507992"/>
-            <a:ext cx="10241280" cy="1024128"/>
-          </a:xfrm>
-          <a:prstGeom prst="rect">
-            <a:avLst/>
-          </a:prstGeom>
-        </p:spPr>
-      </p:pic>
-      <p:sp>
-        <p:nvSpPr>
-          <p:cNvPr id="14" name="Shape 9"/>
-          <p:cNvSpPr/>
-          <p:nvPr/>
-        </p:nvSpPr>
-        <p:spPr>
-          <a:xfrm>
-            <a:off x="914400" y="4507992"/>
-            <a:ext cx="10241280" cy="1024128"/>
-          </a:xfrm>
-          <a:prstGeom prst="rect">
-            <a:avLst/>
-          </a:prstGeom>
-          <a:solidFill>
-            <a:srgbClr val="FFFFFF">
-              <a:alpha val="0"/>
-            </a:srgbClr>
-          </a:solidFill>
-          <a:ln w="12700">
-            <a:solidFill>
-              <a:srgbClr val="E5E7EB">
-                <a:alpha val="0"/>
-              </a:srgbClr>
-            </a:solidFill>
-            <a:prstDash val="solid"/>
-          </a:ln>
-          <a:effectLst>
-            <a:outerShdw sx="100000" sy="100000" kx="0" ky="0" algn="bl" rotWithShape="0" blurRad="12700" dist="50800" dir="2700000">
-              <a:srgbClr val="000000">
-                <a:alpha val="8000"/>
-              </a:srgbClr>
-            </a:outerShdw>
-          </a:effectLst>
-        </p:spPr>
-      </p:sp>
-      <p:sp>
-        <p:nvSpPr>
-          <p:cNvPr id="15" name="Shape 10"/>
-          <p:cNvSpPr/>
-          <p:nvPr/>
-        </p:nvSpPr>
-        <p:spPr>
-          <a:xfrm>
-            <a:off x="786384" y="1956816"/>
-            <a:ext cx="32004" cy="3483864"/>
-          </a:xfrm>
-          <a:prstGeom prst="rect">
-            <a:avLst/>
-          </a:prstGeom>
-          <a:solidFill>
-            <a:srgbClr val="38BDF8">
-              <a:alpha val="80000"/>
-            </a:srgbClr>
+        </p:spPr>
+      </p:sp>
+      <p:sp>
+        <p:nvSpPr>
+          <p:cNvPr id="10" name="Shape 8"/>
+          <p:cNvSpPr/>
+          <p:nvPr/>
+        </p:nvSpPr>
+        <p:spPr>
+          <a:xfrm>
+            <a:off x="4343400" y="1938528"/>
+            <a:ext cx="73152" cy="2514600"/>
+          </a:xfrm>
+          <a:prstGeom prst="rect">
+            <a:avLst/>
+          </a:prstGeom>
+          <a:solidFill>
+            <a:srgbClr val="38BDF8"/>
           </a:solidFill>
           <a:ln w="12700">
             <a:solidFill>
@@ -18618,14 +17755,14 @@
       </p:sp>
       <p:sp>
         <p:nvSpPr>
-          <p:cNvPr id="16" name="Shape 11"/>
-          <p:cNvSpPr/>
-          <p:nvPr/>
-        </p:nvSpPr>
-        <p:spPr>
-          <a:xfrm>
-            <a:off x="914400" y="1865376"/>
-            <a:ext cx="73152" cy="1024128"/>
+          <p:cNvPr id="11" name="Shape 9"/>
+          <p:cNvSpPr/>
+          <p:nvPr/>
+        </p:nvSpPr>
+        <p:spPr>
+          <a:xfrm>
+            <a:off x="7863840" y="1938528"/>
+            <a:ext cx="73152" cy="2514600"/>
           </a:xfrm>
           <a:prstGeom prst="rect">
             <a:avLst/>
@@ -18645,61 +17782,7 @@
       </p:sp>
       <p:sp>
         <p:nvSpPr>
-          <p:cNvPr id="17" name="Shape 12"/>
-          <p:cNvSpPr/>
-          <p:nvPr/>
-        </p:nvSpPr>
-        <p:spPr>
-          <a:xfrm>
-            <a:off x="914400" y="3191256"/>
-            <a:ext cx="73152" cy="1024128"/>
-          </a:xfrm>
-          <a:prstGeom prst="rect">
-            <a:avLst/>
-          </a:prstGeom>
-          <a:solidFill>
-            <a:srgbClr val="38BDF8"/>
-          </a:solidFill>
-          <a:ln w="12700">
-            <a:solidFill>
-              <a:srgbClr val="38BDF8">
-                <a:alpha val="0"/>
-              </a:srgbClr>
-            </a:solidFill>
-            <a:prstDash val="solid"/>
-          </a:ln>
-        </p:spPr>
-      </p:sp>
-      <p:sp>
-        <p:nvSpPr>
-          <p:cNvPr id="18" name="Shape 13"/>
-          <p:cNvSpPr/>
-          <p:nvPr/>
-        </p:nvSpPr>
-        <p:spPr>
-          <a:xfrm>
-            <a:off x="914400" y="4507992"/>
-            <a:ext cx="73152" cy="1024128"/>
-          </a:xfrm>
-          <a:prstGeom prst="rect">
-            <a:avLst/>
-          </a:prstGeom>
-          <a:solidFill>
-            <a:srgbClr val="F43F5E"/>
-          </a:solidFill>
-          <a:ln w="12700">
-            <a:solidFill>
-              <a:srgbClr val="F43F5E">
-                <a:alpha val="0"/>
-              </a:srgbClr>
-            </a:solidFill>
-            <a:prstDash val="solid"/>
-          </a:ln>
-        </p:spPr>
-      </p:sp>
-      <p:sp>
-        <p:nvSpPr>
-          <p:cNvPr id="19" name="mdpr:actions-output-review-326e07:title:__title:actions-output-review-326e07"/>
+          <p:cNvPr id="12" name="mdpr:actions-output-review-326e07:title:__title:actions-output-review-326e07"/>
           <p:cNvSpPr txBox="1"/>
           <p:nvPr/>
         </p:nvSpPr>
@@ -18741,14 +17824,14 @@
       </p:sp>
       <p:sp>
         <p:nvSpPr>
-          <p:cNvPr id="20" name="mdpr:actions-output-review-326e07:item-1:block-41"/>
+          <p:cNvPr id="13" name="mdpr:actions-output-review-326e07:item-1:block-41"/>
           <p:cNvSpPr txBox="1"/>
           <p:nvPr/>
         </p:nvSpPr>
         <p:spPr>
           <a:xfrm>
-            <a:off x="1133856" y="1957548"/>
-            <a:ext cx="9820656" cy="839785"/>
+            <a:off x="1042416" y="2103120"/>
+            <a:ext cx="2825496" cy="2185416"/>
           </a:xfrm>
           <a:prstGeom prst="rect">
             <a:avLst/>
@@ -18800,14 +17883,14 @@
       </p:sp>
       <p:sp>
         <p:nvSpPr>
-          <p:cNvPr id="21" name="mdpr:actions-output-review-326e07:item-2:block-41"/>
+          <p:cNvPr id="14" name="mdpr:actions-output-review-326e07:item-2:block-41"/>
           <p:cNvSpPr txBox="1"/>
           <p:nvPr/>
         </p:nvSpPr>
         <p:spPr>
           <a:xfrm>
-            <a:off x="1133856" y="3283428"/>
-            <a:ext cx="9820656" cy="839785"/>
+            <a:off x="4562856" y="2103120"/>
+            <a:ext cx="2825496" cy="2185416"/>
           </a:xfrm>
           <a:prstGeom prst="rect">
             <a:avLst/>
@@ -18859,14 +17942,14 @@
       </p:sp>
       <p:sp>
         <p:nvSpPr>
-          <p:cNvPr id="22" name="mdpr:actions-output-review-326e07:item-3:block-41"/>
+          <p:cNvPr id="15" name="mdpr:actions-output-review-326e07:item-3:block-41"/>
           <p:cNvSpPr txBox="1"/>
           <p:nvPr/>
         </p:nvSpPr>
         <p:spPr>
           <a:xfrm>
-            <a:off x="1133856" y="4600164"/>
-            <a:ext cx="9820656" cy="839785"/>
+            <a:off x="8083296" y="2103120"/>
+            <a:ext cx="2825496" cy="2185416"/>
           </a:xfrm>
           <a:prstGeom prst="rect">
             <a:avLst/>
@@ -19176,8 +18259,8 @@
         </p:nvSpPr>
         <p:spPr>
           <a:xfrm>
-            <a:off x="822960" y="3099816"/>
-            <a:ext cx="10515600" cy="45720"/>
+            <a:off x="822960" y="1737360"/>
+            <a:ext cx="73152" cy="841248"/>
           </a:xfrm>
           <a:prstGeom prst="rect">
             <a:avLst/>
@@ -19203,8 +18286,8 @@
         </p:nvSpPr>
         <p:spPr>
           <a:xfrm>
-            <a:off x="822960" y="4288536"/>
-            <a:ext cx="2011680" cy="45720"/>
+            <a:off x="822960" y="2779776"/>
+            <a:ext cx="73152" cy="841248"/>
           </a:xfrm>
           <a:prstGeom prst="rect">
             <a:avLst/>
@@ -19230,7 +18313,7 @@
         </p:nvSpPr>
         <p:spPr>
           <a:xfrm>
-            <a:off x="822960" y="3300984"/>
+            <a:off x="822960" y="3822192"/>
             <a:ext cx="73152" cy="841248"/>
           </a:xfrm>
           <a:prstGeom prst="rect">
@@ -19251,7 +18334,115 @@
       </p:sp>
       <p:sp>
         <p:nvSpPr>
-          <p:cNvPr id="12" name="mdpr:2-2-7bfb60:title:__title:2-2-7bfb60"/>
+          <p:cNvPr id="12" name="Shape 10"/>
+          <p:cNvSpPr/>
+          <p:nvPr/>
+        </p:nvSpPr>
+        <p:spPr>
+          <a:xfrm>
+            <a:off x="822960" y="4864608"/>
+            <a:ext cx="73152" cy="841248"/>
+          </a:xfrm>
+          <a:prstGeom prst="rect">
+            <a:avLst/>
+          </a:prstGeom>
+          <a:solidFill>
+            <a:srgbClr val="38BDF8"/>
+          </a:solidFill>
+          <a:ln w="12700">
+            <a:solidFill>
+              <a:srgbClr val="38BDF8">
+                <a:alpha val="0"/>
+              </a:srgbClr>
+            </a:solidFill>
+            <a:prstDash val="solid"/>
+          </a:ln>
+        </p:spPr>
+      </p:sp>
+      <p:sp>
+        <p:nvSpPr>
+          <p:cNvPr id="13" name="Shape 11"/>
+          <p:cNvSpPr/>
+          <p:nvPr/>
+        </p:nvSpPr>
+        <p:spPr>
+          <a:xfrm>
+            <a:off x="6272784" y="1737360"/>
+            <a:ext cx="73152" cy="841248"/>
+          </a:xfrm>
+          <a:prstGeom prst="rect">
+            <a:avLst/>
+          </a:prstGeom>
+          <a:solidFill>
+            <a:srgbClr val="F43F5E"/>
+          </a:solidFill>
+          <a:ln w="12700">
+            <a:solidFill>
+              <a:srgbClr val="F43F5E">
+                <a:alpha val="0"/>
+              </a:srgbClr>
+            </a:solidFill>
+            <a:prstDash val="solid"/>
+          </a:ln>
+        </p:spPr>
+      </p:sp>
+      <p:sp>
+        <p:nvSpPr>
+          <p:cNvPr id="14" name="Shape 12"/>
+          <p:cNvSpPr/>
+          <p:nvPr/>
+        </p:nvSpPr>
+        <p:spPr>
+          <a:xfrm>
+            <a:off x="6272784" y="2779776"/>
+            <a:ext cx="73152" cy="841248"/>
+          </a:xfrm>
+          <a:prstGeom prst="rect">
+            <a:avLst/>
+          </a:prstGeom>
+          <a:solidFill>
+            <a:srgbClr val="38BDF8"/>
+          </a:solidFill>
+          <a:ln w="12700">
+            <a:solidFill>
+              <a:srgbClr val="38BDF8">
+                <a:alpha val="0"/>
+              </a:srgbClr>
+            </a:solidFill>
+            <a:prstDash val="solid"/>
+          </a:ln>
+        </p:spPr>
+      </p:sp>
+      <p:sp>
+        <p:nvSpPr>
+          <p:cNvPr id="15" name="Shape 13"/>
+          <p:cNvSpPr/>
+          <p:nvPr/>
+        </p:nvSpPr>
+        <p:spPr>
+          <a:xfrm>
+            <a:off x="6272784" y="3822192"/>
+            <a:ext cx="73152" cy="841248"/>
+          </a:xfrm>
+          <a:prstGeom prst="rect">
+            <a:avLst/>
+          </a:prstGeom>
+          <a:solidFill>
+            <a:srgbClr val="F43F5E"/>
+          </a:solidFill>
+          <a:ln w="12700">
+            <a:solidFill>
+              <a:srgbClr val="F43F5E">
+                <a:alpha val="0"/>
+              </a:srgbClr>
+            </a:solidFill>
+            <a:prstDash val="solid"/>
+          </a:ln>
+        </p:spPr>
+      </p:sp>
+      <p:sp>
+        <p:nvSpPr>
+          <p:cNvPr id="16" name="mdpr:2-2-7bfb60:title:__title:2-2-7bfb60"/>
           <p:cNvSpPr txBox="1"/>
           <p:nvPr/>
         </p:nvSpPr>
@@ -19285,7 +18476,24 @@
                 <a:ea typeface="Pretendard" pitchFamily="34" charset="-122"/>
                 <a:cs typeface="Pretendard" pitchFamily="34" charset="-120"/>
               </a:rPr>
-              <a:t>Agenda (Cont. 2/2)</a:t>
+              <a:t>Agenda</a:t>
+            </a:r>
+            <a:pPr algn="ctr" indent="0" marL="0">
+              <a:lnSpc>
+                <a:spcPct val="120000"/>
+              </a:lnSpc>
+              <a:buNone/>
+            </a:pPr>
+            <a:r>
+              <a:rPr lang="en-US" sz="2300" dirty="0">
+                <a:solidFill>
+                  <a:srgbClr val="8F8F8F"/>
+                </a:solidFill>
+                <a:latin typeface="Pretendard" pitchFamily="34" charset="0"/>
+                <a:ea typeface="Pretendard" pitchFamily="34" charset="-122"/>
+                <a:cs typeface="Pretendard" pitchFamily="34" charset="-120"/>
+              </a:rPr>
+              <a:t> (Cont. 2/2)</a:t>
             </a:r>
             <a:endParaRPr lang="en-US" sz="3800" dirty="0"/>
           </a:p>
@@ -19293,14 +18501,14 @@
       </p:sp>
       <p:sp>
         <p:nvSpPr>
-          <p:cNvPr id="13" name="mdpr:2-2-7bfb60:toc-item-1:toc-item-15"/>
+          <p:cNvPr id="17" name="mdpr:2-2-7bfb60:toc-item-1:toc-item-9"/>
           <p:cNvSpPr txBox="1"/>
           <p:nvPr/>
         </p:nvSpPr>
         <p:spPr>
           <a:xfrm>
-            <a:off x="1042416" y="3392424"/>
-            <a:ext cx="10094976" cy="658368"/>
+            <a:off x="1042416" y="1828800"/>
+            <a:ext cx="4645152" cy="658368"/>
           </a:xfrm>
           <a:prstGeom prst="rect">
             <a:avLst/>
@@ -19319,7 +18527,7 @@
               <a:buNone/>
             </a:pPr>
             <a:r>
-              <a:rPr lang="en-US" sz="2200" dirty="0">
+              <a:rPr lang="en-US" sz="1800" dirty="0">
                 <a:solidFill>
                   <a:srgbClr val="111111"/>
                 </a:solidFill>
@@ -19327,9 +18535,261 @@
                 <a:ea typeface="Pretendard" pitchFamily="34" charset="-122"/>
                 <a:cs typeface="Pretendard" pitchFamily="34" charset="-120"/>
               </a:rPr>
-              <a:t>01  Actions Output Review</a:t>
+              <a:t>09  Editable Proof Objects</a:t>
             </a:r>
-            <a:endParaRPr lang="en-US" sz="2200" dirty="0"/>
+            <a:endParaRPr lang="en-US" sz="1800" dirty="0"/>
+          </a:p>
+        </p:txBody>
+      </p:sp>
+      <p:sp>
+        <p:nvSpPr>
+          <p:cNvPr id="18" name="mdpr:2-2-7bfb60:toc-item-2:toc-item-10"/>
+          <p:cNvSpPr txBox="1"/>
+          <p:nvPr/>
+        </p:nvSpPr>
+        <p:spPr>
+          <a:xfrm>
+            <a:off x="1042416" y="2871216"/>
+            <a:ext cx="4645152" cy="658368"/>
+          </a:xfrm>
+          <a:prstGeom prst="rect">
+            <a:avLst/>
+          </a:prstGeom>
+          <a:noFill/>
+          <a:ln/>
+        </p:spPr>
+        <p:txBody>
+          <a:bodyPr wrap="square" lIns="0" tIns="25400" rIns="25400" bIns="0" rtlCol="0" anchor="ctr"/>
+          <a:lstStyle/>
+          <a:p>
+            <a:pPr algn="ctr" indent="0" marL="0">
+              <a:lnSpc>
+                <a:spcPct val="120000"/>
+              </a:lnSpc>
+              <a:buNone/>
+            </a:pPr>
+            <a:r>
+              <a:rPr lang="en-US" sz="1800" dirty="0">
+                <a:solidFill>
+                  <a:srgbClr val="111111"/>
+                </a:solidFill>
+                <a:latin typeface="Pretendard" pitchFamily="34" charset="0"/>
+                <a:ea typeface="Pretendard" pitchFamily="34" charset="-122"/>
+                <a:cs typeface="Pretendard" pitchFamily="34" charset="-120"/>
+              </a:rPr>
+              <a:t>10  Object Shape Grammar</a:t>
+            </a:r>
+            <a:endParaRPr lang="en-US" sz="1800" dirty="0"/>
+          </a:p>
+        </p:txBody>
+      </p:sp>
+      <p:sp>
+        <p:nvSpPr>
+          <p:cNvPr id="19" name="mdpr:2-2-7bfb60:toc-item-3:toc-item-11"/>
+          <p:cNvSpPr txBox="1"/>
+          <p:nvPr/>
+        </p:nvSpPr>
+        <p:spPr>
+          <a:xfrm>
+            <a:off x="1042416" y="3913632"/>
+            <a:ext cx="4645152" cy="658368"/>
+          </a:xfrm>
+          <a:prstGeom prst="rect">
+            <a:avLst/>
+          </a:prstGeom>
+          <a:noFill/>
+          <a:ln/>
+        </p:spPr>
+        <p:txBody>
+          <a:bodyPr wrap="square" lIns="0" tIns="25400" rIns="25400" bIns="0" rtlCol="0" anchor="ctr"/>
+          <a:lstStyle/>
+          <a:p>
+            <a:pPr algn="ctr" indent="0" marL="0">
+              <a:lnSpc>
+                <a:spcPct val="120000"/>
+              </a:lnSpc>
+              <a:buNone/>
+            </a:pPr>
+            <a:r>
+              <a:rPr lang="en-US" sz="1800" dirty="0">
+                <a:solidFill>
+                  <a:srgbClr val="111111"/>
+                </a:solidFill>
+                <a:latin typeface="Pretendard" pitchFamily="34" charset="0"/>
+                <a:ea typeface="Pretendard" pitchFamily="34" charset="-122"/>
+                <a:cs typeface="Pretendard" pitchFamily="34" charset="-120"/>
+              </a:rPr>
+              <a:t>11  Icon and Text Aside</a:t>
+            </a:r>
+            <a:endParaRPr lang="en-US" sz="1800" dirty="0"/>
+          </a:p>
+        </p:txBody>
+      </p:sp>
+      <p:sp>
+        <p:nvSpPr>
+          <p:cNvPr id="20" name="mdpr:2-2-7bfb60:toc-item-4:toc-item-12"/>
+          <p:cNvSpPr txBox="1"/>
+          <p:nvPr/>
+        </p:nvSpPr>
+        <p:spPr>
+          <a:xfrm>
+            <a:off x="1042416" y="4956048"/>
+            <a:ext cx="4645152" cy="658368"/>
+          </a:xfrm>
+          <a:prstGeom prst="rect">
+            <a:avLst/>
+          </a:prstGeom>
+          <a:noFill/>
+          <a:ln/>
+        </p:spPr>
+        <p:txBody>
+          <a:bodyPr wrap="square" lIns="0" tIns="25400" rIns="25400" bIns="0" rtlCol="0" anchor="ctr"/>
+          <a:lstStyle/>
+          <a:p>
+            <a:pPr algn="ctr" indent="0" marL="0">
+              <a:lnSpc>
+                <a:spcPct val="120000"/>
+              </a:lnSpc>
+              <a:buNone/>
+            </a:pPr>
+            <a:r>
+              <a:rPr lang="en-US" sz="1800" dirty="0">
+                <a:solidFill>
+                  <a:srgbClr val="111111"/>
+                </a:solidFill>
+                <a:latin typeface="Pretendard" pitchFamily="34" charset="0"/>
+                <a:ea typeface="Pretendard" pitchFamily="34" charset="-122"/>
+                <a:cs typeface="Pretendard" pitchFamily="34" charset="-120"/>
+              </a:rPr>
+              <a:t>12  Overflow Guard</a:t>
+            </a:r>
+            <a:endParaRPr lang="en-US" sz="1800" dirty="0"/>
+          </a:p>
+        </p:txBody>
+      </p:sp>
+      <p:sp>
+        <p:nvSpPr>
+          <p:cNvPr id="21" name="mdpr:2-2-7bfb60:toc-item-5:toc-item-13"/>
+          <p:cNvSpPr txBox="1"/>
+          <p:nvPr/>
+        </p:nvSpPr>
+        <p:spPr>
+          <a:xfrm>
+            <a:off x="6492240" y="1828800"/>
+            <a:ext cx="4645152" cy="658368"/>
+          </a:xfrm>
+          <a:prstGeom prst="rect">
+            <a:avLst/>
+          </a:prstGeom>
+          <a:noFill/>
+          <a:ln/>
+        </p:spPr>
+        <p:txBody>
+          <a:bodyPr wrap="square" lIns="0" tIns="25400" rIns="25400" bIns="0" rtlCol="0" anchor="ctr"/>
+          <a:lstStyle/>
+          <a:p>
+            <a:pPr algn="ctr" indent="0" marL="0">
+              <a:lnSpc>
+                <a:spcPct val="120000"/>
+              </a:lnSpc>
+              <a:buNone/>
+            </a:pPr>
+            <a:r>
+              <a:rPr lang="en-US" sz="1800" dirty="0">
+                <a:solidFill>
+                  <a:srgbClr val="111111"/>
+                </a:solidFill>
+                <a:latin typeface="Pretendard" pitchFamily="34" charset="0"/>
+                <a:ea typeface="Pretendard" pitchFamily="34" charset="-122"/>
+                <a:cs typeface="Pretendard" pitchFamily="34" charset="-120"/>
+              </a:rPr>
+              <a:t>13  Image Safe Frame</a:t>
+            </a:r>
+            <a:endParaRPr lang="en-US" sz="1800" dirty="0"/>
+          </a:p>
+        </p:txBody>
+      </p:sp>
+      <p:sp>
+        <p:nvSpPr>
+          <p:cNvPr id="22" name="mdpr:2-2-7bfb60:toc-item-6:toc-item-14"/>
+          <p:cNvSpPr txBox="1"/>
+          <p:nvPr/>
+        </p:nvSpPr>
+        <p:spPr>
+          <a:xfrm>
+            <a:off x="6492240" y="2871216"/>
+            <a:ext cx="4645152" cy="658368"/>
+          </a:xfrm>
+          <a:prstGeom prst="rect">
+            <a:avLst/>
+          </a:prstGeom>
+          <a:noFill/>
+          <a:ln/>
+        </p:spPr>
+        <p:txBody>
+          <a:bodyPr wrap="square" lIns="0" tIns="25400" rIns="25400" bIns="0" rtlCol="0" anchor="ctr"/>
+          <a:lstStyle/>
+          <a:p>
+            <a:pPr algn="ctr" indent="0" marL="0">
+              <a:lnSpc>
+                <a:spcPct val="120000"/>
+              </a:lnSpc>
+              <a:buNone/>
+            </a:pPr>
+            <a:r>
+              <a:rPr lang="en-US" sz="1800" dirty="0">
+                <a:solidFill>
+                  <a:srgbClr val="111111"/>
+                </a:solidFill>
+                <a:latin typeface="Pretendard" pitchFamily="34" charset="0"/>
+                <a:ea typeface="Pretendard" pitchFamily="34" charset="-122"/>
+                <a:cs typeface="Pretendard" pitchFamily="34" charset="-120"/>
+              </a:rPr>
+              <a:t>14  Mixed Object Packing</a:t>
+            </a:r>
+            <a:endParaRPr lang="en-US" sz="1800" dirty="0"/>
+          </a:p>
+        </p:txBody>
+      </p:sp>
+      <p:sp>
+        <p:nvSpPr>
+          <p:cNvPr id="23" name="mdpr:2-2-7bfb60:toc-item-7:toc-item-15"/>
+          <p:cNvSpPr txBox="1"/>
+          <p:nvPr/>
+        </p:nvSpPr>
+        <p:spPr>
+          <a:xfrm>
+            <a:off x="6492240" y="3913632"/>
+            <a:ext cx="4645152" cy="658368"/>
+          </a:xfrm>
+          <a:prstGeom prst="rect">
+            <a:avLst/>
+          </a:prstGeom>
+          <a:noFill/>
+          <a:ln/>
+        </p:spPr>
+        <p:txBody>
+          <a:bodyPr wrap="square" lIns="0" tIns="25400" rIns="25400" bIns="0" rtlCol="0" anchor="ctr"/>
+          <a:lstStyle/>
+          <a:p>
+            <a:pPr algn="ctr" indent="0" marL="0">
+              <a:lnSpc>
+                <a:spcPct val="120000"/>
+              </a:lnSpc>
+              <a:buNone/>
+            </a:pPr>
+            <a:r>
+              <a:rPr lang="en-US" sz="1800" dirty="0">
+                <a:solidFill>
+                  <a:srgbClr val="111111"/>
+                </a:solidFill>
+                <a:latin typeface="Pretendard" pitchFamily="34" charset="0"/>
+                <a:ea typeface="Pretendard" pitchFamily="34" charset="-122"/>
+                <a:cs typeface="Pretendard" pitchFamily="34" charset="-120"/>
+              </a:rPr>
+              <a:t>15  Actions Output Review</a:t>
+            </a:r>
+            <a:endParaRPr lang="en-US" sz="1800" dirty="0"/>
           </a:p>
         </p:txBody>
       </p:sp>
@@ -20222,222 +19682,49 @@
           </a:ln>
         </p:spPr>
       </p:sp>
-      <p:pic>
-        <p:nvPicPr>
-          <p:cNvPr id="9" name="Image 0" descr="preencoded.png">    </p:cNvPr>
-          <p:cNvPicPr>
-            <a:picLocks noChangeAspect="1"/>
-          </p:cNvPicPr>
-          <p:nvPr/>
-        </p:nvPicPr>
-        <p:blipFill>
-          <a:blip r:embed="rId1">
-            <a:extLst>
-              <a:ext uri="{96DAC541-7B7A-43D3-8B79-37D633B846F1}">
-                <asvg:svgBlip xmlns:asvg="http://schemas.microsoft.com/office/drawing/2016/SVG/main" r:embed="rId2"/>
-              </a:ext>
-            </a:extLst>
-          </a:blip>
-          <a:stretch>
-            <a:fillRect/>
-          </a:stretch>
-        </p:blipFill>
-        <p:spPr>
-          <a:xfrm>
-            <a:off x="914400" y="1865376"/>
-            <a:ext cx="10241280" cy="1024128"/>
-          </a:xfrm>
-          <a:prstGeom prst="rect">
-            <a:avLst/>
-          </a:prstGeom>
-        </p:spPr>
-      </p:pic>
-      <p:sp>
-        <p:nvSpPr>
-          <p:cNvPr id="10" name="Shape 7"/>
-          <p:cNvSpPr/>
-          <p:nvPr/>
-        </p:nvSpPr>
-        <p:spPr>
-          <a:xfrm>
-            <a:off x="914400" y="1865376"/>
-            <a:ext cx="10241280" cy="1024128"/>
-          </a:xfrm>
-          <a:prstGeom prst="rect">
-            <a:avLst/>
-          </a:prstGeom>
-          <a:solidFill>
-            <a:srgbClr val="FFFFFF">
-              <a:alpha val="0"/>
-            </a:srgbClr>
-          </a:solidFill>
-          <a:ln w="12700">
-            <a:solidFill>
-              <a:srgbClr val="E5E7EB">
+      <p:sp>
+        <p:nvSpPr>
+          <p:cNvPr id="9" name="Shape 7"/>
+          <p:cNvSpPr/>
+          <p:nvPr/>
+        </p:nvSpPr>
+        <p:spPr>
+          <a:xfrm>
+            <a:off x="822960" y="1938528"/>
+            <a:ext cx="73152" cy="2514600"/>
+          </a:xfrm>
+          <a:prstGeom prst="rect">
+            <a:avLst/>
+          </a:prstGeom>
+          <a:solidFill>
+            <a:srgbClr val="F43F5E"/>
+          </a:solidFill>
+          <a:ln w="12700">
+            <a:solidFill>
+              <a:srgbClr val="F43F5E">
                 <a:alpha val="0"/>
               </a:srgbClr>
             </a:solidFill>
             <a:prstDash val="solid"/>
           </a:ln>
-          <a:effectLst>
-            <a:outerShdw sx="100000" sy="100000" kx="0" ky="0" algn="bl" rotWithShape="0" blurRad="12700" dist="50800" dir="2700000">
-              <a:srgbClr val="000000">
-                <a:alpha val="8000"/>
-              </a:srgbClr>
-            </a:outerShdw>
-          </a:effectLst>
-        </p:spPr>
-      </p:sp>
-      <p:pic>
-        <p:nvPicPr>
-          <p:cNvPr id="11" name="Image 1" descr="preencoded.png">    </p:cNvPr>
-          <p:cNvPicPr>
-            <a:picLocks noChangeAspect="1"/>
-          </p:cNvPicPr>
-          <p:nvPr/>
-        </p:nvPicPr>
-        <p:blipFill>
-          <a:blip r:embed="rId3">
-            <a:extLst>
-              <a:ext uri="{96DAC541-7B7A-43D3-8B79-37D633B846F1}">
-                <asvg:svgBlip xmlns:asvg="http://schemas.microsoft.com/office/drawing/2016/SVG/main" r:embed="rId4"/>
-              </a:ext>
-            </a:extLst>
-          </a:blip>
-          <a:stretch>
-            <a:fillRect/>
-          </a:stretch>
-        </p:blipFill>
-        <p:spPr>
-          <a:xfrm>
-            <a:off x="914400" y="3191256"/>
-            <a:ext cx="10241280" cy="1024128"/>
-          </a:xfrm>
-          <a:prstGeom prst="rect">
-            <a:avLst/>
-          </a:prstGeom>
-        </p:spPr>
-      </p:pic>
-      <p:sp>
-        <p:nvSpPr>
-          <p:cNvPr id="12" name="Shape 8"/>
-          <p:cNvSpPr/>
-          <p:nvPr/>
-        </p:nvSpPr>
-        <p:spPr>
-          <a:xfrm>
-            <a:off x="914400" y="3191256"/>
-            <a:ext cx="10241280" cy="1024128"/>
-          </a:xfrm>
-          <a:prstGeom prst="rect">
-            <a:avLst/>
-          </a:prstGeom>
-          <a:solidFill>
-            <a:srgbClr val="FFFFFF">
-              <a:alpha val="0"/>
-            </a:srgbClr>
-          </a:solidFill>
-          <a:ln w="12700">
-            <a:solidFill>
-              <a:srgbClr val="E5E7EB">
-                <a:alpha val="0"/>
-              </a:srgbClr>
-            </a:solidFill>
-            <a:prstDash val="solid"/>
-          </a:ln>
-          <a:effectLst>
-            <a:outerShdw sx="100000" sy="100000" kx="0" ky="0" algn="bl" rotWithShape="0" blurRad="12700" dist="50800" dir="2700000">
-              <a:srgbClr val="000000">
-                <a:alpha val="8000"/>
-              </a:srgbClr>
-            </a:outerShdw>
-          </a:effectLst>
-        </p:spPr>
-      </p:sp>
-      <p:pic>
-        <p:nvPicPr>
-          <p:cNvPr id="13" name="Image 2" descr="preencoded.png">    </p:cNvPr>
-          <p:cNvPicPr>
-            <a:picLocks noChangeAspect="1"/>
-          </p:cNvPicPr>
-          <p:nvPr/>
-        </p:nvPicPr>
-        <p:blipFill>
-          <a:blip r:embed="rId5">
-            <a:extLst>
-              <a:ext uri="{96DAC541-7B7A-43D3-8B79-37D633B846F1}">
-                <asvg:svgBlip xmlns:asvg="http://schemas.microsoft.com/office/drawing/2016/SVG/main" r:embed="rId6"/>
-              </a:ext>
-            </a:extLst>
-          </a:blip>
-          <a:stretch>
-            <a:fillRect/>
-          </a:stretch>
-        </p:blipFill>
-        <p:spPr>
-          <a:xfrm>
-            <a:off x="914400" y="4507992"/>
-            <a:ext cx="10241280" cy="1024128"/>
-          </a:xfrm>
-          <a:prstGeom prst="rect">
-            <a:avLst/>
-          </a:prstGeom>
-        </p:spPr>
-      </p:pic>
-      <p:sp>
-        <p:nvSpPr>
-          <p:cNvPr id="14" name="Shape 9"/>
-          <p:cNvSpPr/>
-          <p:nvPr/>
-        </p:nvSpPr>
-        <p:spPr>
-          <a:xfrm>
-            <a:off x="914400" y="4507992"/>
-            <a:ext cx="10241280" cy="1024128"/>
-          </a:xfrm>
-          <a:prstGeom prst="rect">
-            <a:avLst/>
-          </a:prstGeom>
-          <a:solidFill>
-            <a:srgbClr val="FFFFFF">
-              <a:alpha val="0"/>
-            </a:srgbClr>
-          </a:solidFill>
-          <a:ln w="12700">
-            <a:solidFill>
-              <a:srgbClr val="E5E7EB">
-                <a:alpha val="0"/>
-              </a:srgbClr>
-            </a:solidFill>
-            <a:prstDash val="solid"/>
-          </a:ln>
-          <a:effectLst>
-            <a:outerShdw sx="100000" sy="100000" kx="0" ky="0" algn="bl" rotWithShape="0" blurRad="12700" dist="50800" dir="2700000">
-              <a:srgbClr val="000000">
-                <a:alpha val="8000"/>
-              </a:srgbClr>
-            </a:outerShdw>
-          </a:effectLst>
-        </p:spPr>
-      </p:sp>
-      <p:sp>
-        <p:nvSpPr>
-          <p:cNvPr id="15" name="Shape 10"/>
-          <p:cNvSpPr/>
-          <p:nvPr/>
-        </p:nvSpPr>
-        <p:spPr>
-          <a:xfrm>
-            <a:off x="786384" y="1956816"/>
-            <a:ext cx="32004" cy="3483864"/>
-          </a:xfrm>
-          <a:prstGeom prst="rect">
-            <a:avLst/>
-          </a:prstGeom>
-          <a:solidFill>
-            <a:srgbClr val="38BDF8">
-              <a:alpha val="80000"/>
-            </a:srgbClr>
+        </p:spPr>
+      </p:sp>
+      <p:sp>
+        <p:nvSpPr>
+          <p:cNvPr id="10" name="Shape 8"/>
+          <p:cNvSpPr/>
+          <p:nvPr/>
+        </p:nvSpPr>
+        <p:spPr>
+          <a:xfrm>
+            <a:off x="4343400" y="1938528"/>
+            <a:ext cx="73152" cy="2514600"/>
+          </a:xfrm>
+          <a:prstGeom prst="rect">
+            <a:avLst/>
+          </a:prstGeom>
+          <a:solidFill>
+            <a:srgbClr val="38BDF8"/>
           </a:solidFill>
           <a:ln w="12700">
             <a:solidFill>
@@ -20451,14 +19738,14 @@
       </p:sp>
       <p:sp>
         <p:nvSpPr>
-          <p:cNvPr id="16" name="Shape 11"/>
-          <p:cNvSpPr/>
-          <p:nvPr/>
-        </p:nvSpPr>
-        <p:spPr>
-          <a:xfrm>
-            <a:off x="914400" y="1865376"/>
-            <a:ext cx="73152" cy="1024128"/>
+          <p:cNvPr id="11" name="Shape 9"/>
+          <p:cNvSpPr/>
+          <p:nvPr/>
+        </p:nvSpPr>
+        <p:spPr>
+          <a:xfrm>
+            <a:off x="7863840" y="1938528"/>
+            <a:ext cx="73152" cy="2514600"/>
           </a:xfrm>
           <a:prstGeom prst="rect">
             <a:avLst/>
@@ -20478,61 +19765,7 @@
       </p:sp>
       <p:sp>
         <p:nvSpPr>
-          <p:cNvPr id="17" name="Shape 12"/>
-          <p:cNvSpPr/>
-          <p:nvPr/>
-        </p:nvSpPr>
-        <p:spPr>
-          <a:xfrm>
-            <a:off x="914400" y="3191256"/>
-            <a:ext cx="73152" cy="1024128"/>
-          </a:xfrm>
-          <a:prstGeom prst="rect">
-            <a:avLst/>
-          </a:prstGeom>
-          <a:solidFill>
-            <a:srgbClr val="38BDF8"/>
-          </a:solidFill>
-          <a:ln w="12700">
-            <a:solidFill>
-              <a:srgbClr val="38BDF8">
-                <a:alpha val="0"/>
-              </a:srgbClr>
-            </a:solidFill>
-            <a:prstDash val="solid"/>
-          </a:ln>
-        </p:spPr>
-      </p:sp>
-      <p:sp>
-        <p:nvSpPr>
-          <p:cNvPr id="18" name="Shape 13"/>
-          <p:cNvSpPr/>
-          <p:nvPr/>
-        </p:nvSpPr>
-        <p:spPr>
-          <a:xfrm>
-            <a:off x="914400" y="4507992"/>
-            <a:ext cx="73152" cy="1024128"/>
-          </a:xfrm>
-          <a:prstGeom prst="rect">
-            <a:avLst/>
-          </a:prstGeom>
-          <a:solidFill>
-            <a:srgbClr val="F43F5E"/>
-          </a:solidFill>
-          <a:ln w="12700">
-            <a:solidFill>
-              <a:srgbClr val="F43F5E">
-                <a:alpha val="0"/>
-              </a:srgbClr>
-            </a:solidFill>
-            <a:prstDash val="solid"/>
-          </a:ln>
-        </p:spPr>
-      </p:sp>
-      <p:sp>
-        <p:nvSpPr>
-          <p:cNvPr id="19" name="mdpr:1-2-32ac08:title:__title:1-2-32ac08"/>
+          <p:cNvPr id="12" name="mdpr:1-2-32ac08:title:__title:1-2-32ac08"/>
           <p:cNvSpPr txBox="1"/>
           <p:nvPr/>
         </p:nvSpPr>
@@ -20574,14 +19807,14 @@
       </p:sp>
       <p:sp>
         <p:nvSpPr>
-          <p:cNvPr id="20" name="mdpr:1-2-32ac08:item-1:block-6-chunk-1"/>
+          <p:cNvPr id="13" name="mdpr:1-2-32ac08:item-1:block-6-chunk-1"/>
           <p:cNvSpPr txBox="1"/>
           <p:nvPr/>
         </p:nvSpPr>
         <p:spPr>
           <a:xfrm>
-            <a:off x="1133856" y="1957548"/>
-            <a:ext cx="9820656" cy="839785"/>
+            <a:off x="1042416" y="2103120"/>
+            <a:ext cx="2825496" cy="2185416"/>
           </a:xfrm>
           <a:prstGeom prst="rect">
             <a:avLst/>
@@ -20633,14 +19866,14 @@
       </p:sp>
       <p:sp>
         <p:nvSpPr>
-          <p:cNvPr id="21" name="mdpr:1-2-32ac08:item-2:block-6-chunk-1"/>
+          <p:cNvPr id="14" name="mdpr:1-2-32ac08:item-2:block-6-chunk-1"/>
           <p:cNvSpPr txBox="1"/>
           <p:nvPr/>
         </p:nvSpPr>
         <p:spPr>
           <a:xfrm>
-            <a:off x="1133856" y="3283428"/>
-            <a:ext cx="9820656" cy="839785"/>
+            <a:off x="4562856" y="2103120"/>
+            <a:ext cx="2825496" cy="2185416"/>
           </a:xfrm>
           <a:prstGeom prst="rect">
             <a:avLst/>
@@ -20692,14 +19925,14 @@
       </p:sp>
       <p:sp>
         <p:nvSpPr>
-          <p:cNvPr id="22" name="mdpr:1-2-32ac08:item-3:block-6-chunk-1"/>
+          <p:cNvPr id="15" name="mdpr:1-2-32ac08:item-3:block-6-chunk-1"/>
           <p:cNvSpPr txBox="1"/>
           <p:nvPr/>
         </p:nvSpPr>
         <p:spPr>
           <a:xfrm>
-            <a:off x="1133856" y="4600164"/>
-            <a:ext cx="9820656" cy="839785"/>
+            <a:off x="8083296" y="2103120"/>
+            <a:ext cx="2825496" cy="2185416"/>
           </a:xfrm>
           <a:prstGeom prst="rect">
             <a:avLst/>
@@ -21003,61 +20236,7 @@
       </p:sp>
       <p:sp>
         <p:nvSpPr>
-          <p:cNvPr id="9" name="Shape 7"/>
-          <p:cNvSpPr/>
-          <p:nvPr/>
-        </p:nvSpPr>
-        <p:spPr>
-          <a:xfrm>
-            <a:off x="822960" y="1554480"/>
-            <a:ext cx="4937760" cy="73152"/>
-          </a:xfrm>
-          <a:prstGeom prst="rect">
-            <a:avLst/>
-          </a:prstGeom>
-          <a:solidFill>
-            <a:srgbClr val="F43F5E"/>
-          </a:solidFill>
-          <a:ln w="12700">
-            <a:solidFill>
-              <a:srgbClr val="F43F5E">
-                <a:alpha val="0"/>
-              </a:srgbClr>
-            </a:solidFill>
-            <a:prstDash val="solid"/>
-          </a:ln>
-        </p:spPr>
-      </p:sp>
-      <p:sp>
-        <p:nvSpPr>
-          <p:cNvPr id="10" name="Shape 8"/>
-          <p:cNvSpPr/>
-          <p:nvPr/>
-        </p:nvSpPr>
-        <p:spPr>
-          <a:xfrm>
-            <a:off x="6400800" y="1554480"/>
-            <a:ext cx="4937760" cy="73152"/>
-          </a:xfrm>
-          <a:prstGeom prst="rect">
-            <a:avLst/>
-          </a:prstGeom>
-          <a:solidFill>
-            <a:srgbClr val="F43F5E"/>
-          </a:solidFill>
-          <a:ln w="12700">
-            <a:solidFill>
-              <a:srgbClr val="F43F5E">
-                <a:alpha val="0"/>
-              </a:srgbClr>
-            </a:solidFill>
-            <a:prstDash val="solid"/>
-          </a:ln>
-        </p:spPr>
-      </p:sp>
-      <p:sp>
-        <p:nvSpPr>
-          <p:cNvPr id="11" name="mdpr:2-2-14f8eb:title:__title:2-2-14f8eb"/>
+          <p:cNvPr id="9" name="mdpr:2-2-14f8eb:title:__title:2-2-14f8eb"/>
           <p:cNvSpPr txBox="1"/>
           <p:nvPr/>
         </p:nvSpPr>
@@ -21091,7 +20270,24 @@
                 <a:ea typeface="Pretendard" pitchFamily="34" charset="-122"/>
                 <a:cs typeface="Pretendard" pitchFamily="34" charset="-120"/>
               </a:rPr>
-              <a:t>Composition Contract (Cont. 2/2)</a:t>
+              <a:t>Composition Contract</a:t>
+            </a:r>
+            <a:pPr algn="ctr" indent="0" marL="0">
+              <a:lnSpc>
+                <a:spcPct val="120000"/>
+              </a:lnSpc>
+              <a:buNone/>
+            </a:pPr>
+            <a:r>
+              <a:rPr lang="en-US" sz="2000" dirty="0">
+                <a:solidFill>
+                  <a:srgbClr val="8F8F8F"/>
+                </a:solidFill>
+                <a:latin typeface="Pretendard" pitchFamily="34" charset="0"/>
+                <a:ea typeface="Pretendard" pitchFamily="34" charset="-122"/>
+                <a:cs typeface="Pretendard" pitchFamily="34" charset="-120"/>
+              </a:rPr>
+              <a:t> (Cont. 2/2)</a:t>
             </a:r>
             <a:endParaRPr lang="en-US" sz="3400" dirty="0"/>
           </a:p>
@@ -21099,14 +20295,14 @@
       </p:sp>
       <p:sp>
         <p:nvSpPr>
-          <p:cNvPr id="12" name="mdpr:2-2-14f8eb:left:block-6-chunk-2"/>
+          <p:cNvPr id="10" name="mdpr:2-2-14f8eb:left:block-6-chunk-2"/>
           <p:cNvSpPr txBox="1"/>
           <p:nvPr/>
         </p:nvSpPr>
         <p:spPr>
           <a:xfrm>
-            <a:off x="896112" y="1664208"/>
-            <a:ext cx="4791456" cy="4169664"/>
+            <a:off x="896112" y="1463040"/>
+            <a:ext cx="4791456" cy="4261104"/>
           </a:xfrm>
           <a:prstGeom prst="rect">
             <a:avLst/>
@@ -21158,14 +20354,14 @@
       </p:sp>
       <p:sp>
         <p:nvSpPr>
-          <p:cNvPr id="13" name="mdpr:2-2-14f8eb:right:block-6-chunk-2"/>
+          <p:cNvPr id="11" name="mdpr:2-2-14f8eb:right:block-6-chunk-2"/>
           <p:cNvSpPr txBox="1"/>
           <p:nvPr/>
         </p:nvSpPr>
         <p:spPr>
           <a:xfrm>
-            <a:off x="6473952" y="1664208"/>
-            <a:ext cx="4791456" cy="4169664"/>
+            <a:off x="6473952" y="1463040"/>
+            <a:ext cx="4791456" cy="4261104"/>
           </a:xfrm>
           <a:prstGeom prst="rect">
             <a:avLst/>
@@ -21467,222 +20663,49 @@
           </a:ln>
         </p:spPr>
       </p:sp>
-      <p:pic>
-        <p:nvPicPr>
-          <p:cNvPr id="9" name="Image 0" descr="preencoded.png">    </p:cNvPr>
-          <p:cNvPicPr>
-            <a:picLocks noChangeAspect="1"/>
-          </p:cNvPicPr>
-          <p:nvPr/>
-        </p:nvPicPr>
-        <p:blipFill>
-          <a:blip r:embed="rId1">
-            <a:extLst>
-              <a:ext uri="{96DAC541-7B7A-43D3-8B79-37D633B846F1}">
-                <asvg:svgBlip xmlns:asvg="http://schemas.microsoft.com/office/drawing/2016/SVG/main" r:embed="rId2"/>
-              </a:ext>
-            </a:extLst>
-          </a:blip>
-          <a:stretch>
-            <a:fillRect/>
-          </a:stretch>
-        </p:blipFill>
-        <p:spPr>
-          <a:xfrm>
-            <a:off x="914400" y="1865376"/>
-            <a:ext cx="10241280" cy="1024128"/>
-          </a:xfrm>
-          <a:prstGeom prst="rect">
-            <a:avLst/>
-          </a:prstGeom>
-        </p:spPr>
-      </p:pic>
-      <p:sp>
-        <p:nvSpPr>
-          <p:cNvPr id="10" name="Shape 7"/>
-          <p:cNvSpPr/>
-          <p:nvPr/>
-        </p:nvSpPr>
-        <p:spPr>
-          <a:xfrm>
-            <a:off x="914400" y="1865376"/>
-            <a:ext cx="10241280" cy="1024128"/>
-          </a:xfrm>
-          <a:prstGeom prst="rect">
-            <a:avLst/>
-          </a:prstGeom>
-          <a:solidFill>
-            <a:srgbClr val="FFFFFF">
-              <a:alpha val="0"/>
-            </a:srgbClr>
-          </a:solidFill>
-          <a:ln w="12700">
-            <a:solidFill>
-              <a:srgbClr val="E5E7EB">
+      <p:sp>
+        <p:nvSpPr>
+          <p:cNvPr id="9" name="Shape 7"/>
+          <p:cNvSpPr/>
+          <p:nvPr/>
+        </p:nvSpPr>
+        <p:spPr>
+          <a:xfrm>
+            <a:off x="822960" y="1938528"/>
+            <a:ext cx="73152" cy="2514600"/>
+          </a:xfrm>
+          <a:prstGeom prst="rect">
+            <a:avLst/>
+          </a:prstGeom>
+          <a:solidFill>
+            <a:srgbClr val="F43F5E"/>
+          </a:solidFill>
+          <a:ln w="12700">
+            <a:solidFill>
+              <a:srgbClr val="F43F5E">
                 <a:alpha val="0"/>
               </a:srgbClr>
             </a:solidFill>
             <a:prstDash val="solid"/>
           </a:ln>
-          <a:effectLst>
-            <a:outerShdw sx="100000" sy="100000" kx="0" ky="0" algn="bl" rotWithShape="0" blurRad="12700" dist="50800" dir="2700000">
-              <a:srgbClr val="000000">
-                <a:alpha val="8000"/>
-              </a:srgbClr>
-            </a:outerShdw>
-          </a:effectLst>
-        </p:spPr>
-      </p:sp>
-      <p:pic>
-        <p:nvPicPr>
-          <p:cNvPr id="11" name="Image 1" descr="preencoded.png">    </p:cNvPr>
-          <p:cNvPicPr>
-            <a:picLocks noChangeAspect="1"/>
-          </p:cNvPicPr>
-          <p:nvPr/>
-        </p:nvPicPr>
-        <p:blipFill>
-          <a:blip r:embed="rId3">
-            <a:extLst>
-              <a:ext uri="{96DAC541-7B7A-43D3-8B79-37D633B846F1}">
-                <asvg:svgBlip xmlns:asvg="http://schemas.microsoft.com/office/drawing/2016/SVG/main" r:embed="rId4"/>
-              </a:ext>
-            </a:extLst>
-          </a:blip>
-          <a:stretch>
-            <a:fillRect/>
-          </a:stretch>
-        </p:blipFill>
-        <p:spPr>
-          <a:xfrm>
-            <a:off x="914400" y="3191256"/>
-            <a:ext cx="10241280" cy="1024128"/>
-          </a:xfrm>
-          <a:prstGeom prst="rect">
-            <a:avLst/>
-          </a:prstGeom>
-        </p:spPr>
-      </p:pic>
-      <p:sp>
-        <p:nvSpPr>
-          <p:cNvPr id="12" name="Shape 8"/>
-          <p:cNvSpPr/>
-          <p:nvPr/>
-        </p:nvSpPr>
-        <p:spPr>
-          <a:xfrm>
-            <a:off x="914400" y="3191256"/>
-            <a:ext cx="10241280" cy="1024128"/>
-          </a:xfrm>
-          <a:prstGeom prst="rect">
-            <a:avLst/>
-          </a:prstGeom>
-          <a:solidFill>
-            <a:srgbClr val="FFFFFF">
-              <a:alpha val="0"/>
-            </a:srgbClr>
-          </a:solidFill>
-          <a:ln w="12700">
-            <a:solidFill>
-              <a:srgbClr val="E5E7EB">
-                <a:alpha val="0"/>
-              </a:srgbClr>
-            </a:solidFill>
-            <a:prstDash val="solid"/>
-          </a:ln>
-          <a:effectLst>
-            <a:outerShdw sx="100000" sy="100000" kx="0" ky="0" algn="bl" rotWithShape="0" blurRad="12700" dist="50800" dir="2700000">
-              <a:srgbClr val="000000">
-                <a:alpha val="8000"/>
-              </a:srgbClr>
-            </a:outerShdw>
-          </a:effectLst>
-        </p:spPr>
-      </p:sp>
-      <p:pic>
-        <p:nvPicPr>
-          <p:cNvPr id="13" name="Image 2" descr="preencoded.png">    </p:cNvPr>
-          <p:cNvPicPr>
-            <a:picLocks noChangeAspect="1"/>
-          </p:cNvPicPr>
-          <p:nvPr/>
-        </p:nvPicPr>
-        <p:blipFill>
-          <a:blip r:embed="rId5">
-            <a:extLst>
-              <a:ext uri="{96DAC541-7B7A-43D3-8B79-37D633B846F1}">
-                <asvg:svgBlip xmlns:asvg="http://schemas.microsoft.com/office/drawing/2016/SVG/main" r:embed="rId6"/>
-              </a:ext>
-            </a:extLst>
-          </a:blip>
-          <a:stretch>
-            <a:fillRect/>
-          </a:stretch>
-        </p:blipFill>
-        <p:spPr>
-          <a:xfrm>
-            <a:off x="914400" y="4507992"/>
-            <a:ext cx="10241280" cy="1024128"/>
-          </a:xfrm>
-          <a:prstGeom prst="rect">
-            <a:avLst/>
-          </a:prstGeom>
-        </p:spPr>
-      </p:pic>
-      <p:sp>
-        <p:nvSpPr>
-          <p:cNvPr id="14" name="Shape 9"/>
-          <p:cNvSpPr/>
-          <p:nvPr/>
-        </p:nvSpPr>
-        <p:spPr>
-          <a:xfrm>
-            <a:off x="914400" y="4507992"/>
-            <a:ext cx="10241280" cy="1024128"/>
-          </a:xfrm>
-          <a:prstGeom prst="rect">
-            <a:avLst/>
-          </a:prstGeom>
-          <a:solidFill>
-            <a:srgbClr val="FFFFFF">
-              <a:alpha val="0"/>
-            </a:srgbClr>
-          </a:solidFill>
-          <a:ln w="12700">
-            <a:solidFill>
-              <a:srgbClr val="E5E7EB">
-                <a:alpha val="0"/>
-              </a:srgbClr>
-            </a:solidFill>
-            <a:prstDash val="solid"/>
-          </a:ln>
-          <a:effectLst>
-            <a:outerShdw sx="100000" sy="100000" kx="0" ky="0" algn="bl" rotWithShape="0" blurRad="12700" dist="50800" dir="2700000">
-              <a:srgbClr val="000000">
-                <a:alpha val="8000"/>
-              </a:srgbClr>
-            </a:outerShdw>
-          </a:effectLst>
-        </p:spPr>
-      </p:sp>
-      <p:sp>
-        <p:nvSpPr>
-          <p:cNvPr id="15" name="Shape 10"/>
-          <p:cNvSpPr/>
-          <p:nvPr/>
-        </p:nvSpPr>
-        <p:spPr>
-          <a:xfrm>
-            <a:off x="786384" y="1956816"/>
-            <a:ext cx="32004" cy="3483864"/>
-          </a:xfrm>
-          <a:prstGeom prst="rect">
-            <a:avLst/>
-          </a:prstGeom>
-          <a:solidFill>
-            <a:srgbClr val="38BDF8">
-              <a:alpha val="80000"/>
-            </a:srgbClr>
+        </p:spPr>
+      </p:sp>
+      <p:sp>
+        <p:nvSpPr>
+          <p:cNvPr id="10" name="Shape 8"/>
+          <p:cNvSpPr/>
+          <p:nvPr/>
+        </p:nvSpPr>
+        <p:spPr>
+          <a:xfrm>
+            <a:off x="4343400" y="1938528"/>
+            <a:ext cx="73152" cy="2514600"/>
+          </a:xfrm>
+          <a:prstGeom prst="rect">
+            <a:avLst/>
+          </a:prstGeom>
+          <a:solidFill>
+            <a:srgbClr val="38BDF8"/>
           </a:solidFill>
           <a:ln w="12700">
             <a:solidFill>
@@ -21696,14 +20719,14 @@
       </p:sp>
       <p:sp>
         <p:nvSpPr>
-          <p:cNvPr id="16" name="Shape 11"/>
-          <p:cNvSpPr/>
-          <p:nvPr/>
-        </p:nvSpPr>
-        <p:spPr>
-          <a:xfrm>
-            <a:off x="914400" y="1865376"/>
-            <a:ext cx="73152" cy="1024128"/>
+          <p:cNvPr id="11" name="Shape 9"/>
+          <p:cNvSpPr/>
+          <p:nvPr/>
+        </p:nvSpPr>
+        <p:spPr>
+          <a:xfrm>
+            <a:off x="7863840" y="1938528"/>
+            <a:ext cx="73152" cy="2514600"/>
           </a:xfrm>
           <a:prstGeom prst="rect">
             <a:avLst/>
@@ -21723,61 +20746,7 @@
       </p:sp>
       <p:sp>
         <p:nvSpPr>
-          <p:cNvPr id="17" name="Shape 12"/>
-          <p:cNvSpPr/>
-          <p:nvPr/>
-        </p:nvSpPr>
-        <p:spPr>
-          <a:xfrm>
-            <a:off x="914400" y="3191256"/>
-            <a:ext cx="73152" cy="1024128"/>
-          </a:xfrm>
-          <a:prstGeom prst="rect">
-            <a:avLst/>
-          </a:prstGeom>
-          <a:solidFill>
-            <a:srgbClr val="38BDF8"/>
-          </a:solidFill>
-          <a:ln w="12700">
-            <a:solidFill>
-              <a:srgbClr val="38BDF8">
-                <a:alpha val="0"/>
-              </a:srgbClr>
-            </a:solidFill>
-            <a:prstDash val="solid"/>
-          </a:ln>
-        </p:spPr>
-      </p:sp>
-      <p:sp>
-        <p:nvSpPr>
-          <p:cNvPr id="18" name="Shape 13"/>
-          <p:cNvSpPr/>
-          <p:nvPr/>
-        </p:nvSpPr>
-        <p:spPr>
-          <a:xfrm>
-            <a:off x="914400" y="4507992"/>
-            <a:ext cx="73152" cy="1024128"/>
-          </a:xfrm>
-          <a:prstGeom prst="rect">
-            <a:avLst/>
-          </a:prstGeom>
-          <a:solidFill>
-            <a:srgbClr val="F43F5E"/>
-          </a:solidFill>
-          <a:ln w="12700">
-            <a:solidFill>
-              <a:srgbClr val="F43F5E">
-                <a:alpha val="0"/>
-              </a:srgbClr>
-            </a:solidFill>
-            <a:prstDash val="solid"/>
-          </a:ln>
-        </p:spPr>
-      </p:sp>
-      <p:sp>
-        <p:nvSpPr>
-          <p:cNvPr id="19" name="mdpr:1-2-dfa474:title:__title:1-2-dfa474"/>
+          <p:cNvPr id="12" name="mdpr:1-2-dfa474:title:__title:1-2-dfa474"/>
           <p:cNvSpPr txBox="1"/>
           <p:nvPr/>
         </p:nvSpPr>
@@ -21819,14 +20788,14 @@
       </p:sp>
       <p:sp>
         <p:nvSpPr>
-          <p:cNvPr id="20" name="mdpr:1-2-dfa474:item-1:block-8-chunk-1"/>
+          <p:cNvPr id="13" name="mdpr:1-2-dfa474:item-1:block-8-chunk-1"/>
           <p:cNvSpPr txBox="1"/>
           <p:nvPr/>
         </p:nvSpPr>
         <p:spPr>
           <a:xfrm>
-            <a:off x="1133856" y="1957548"/>
-            <a:ext cx="9820656" cy="839785"/>
+            <a:off x="1042416" y="2103120"/>
+            <a:ext cx="2825496" cy="2185416"/>
           </a:xfrm>
           <a:prstGeom prst="rect">
             <a:avLst/>
@@ -21878,14 +20847,14 @@
       </p:sp>
       <p:sp>
         <p:nvSpPr>
-          <p:cNvPr id="21" name="mdpr:1-2-dfa474:item-2:block-8-chunk-1"/>
+          <p:cNvPr id="14" name="mdpr:1-2-dfa474:item-2:block-8-chunk-1"/>
           <p:cNvSpPr txBox="1"/>
           <p:nvPr/>
         </p:nvSpPr>
         <p:spPr>
           <a:xfrm>
-            <a:off x="1133856" y="3283428"/>
-            <a:ext cx="9820656" cy="839785"/>
+            <a:off x="4562856" y="2103120"/>
+            <a:ext cx="2825496" cy="2185416"/>
           </a:xfrm>
           <a:prstGeom prst="rect">
             <a:avLst/>
@@ -21937,14 +20906,14 @@
       </p:sp>
       <p:sp>
         <p:nvSpPr>
-          <p:cNvPr id="22" name="mdpr:1-2-dfa474:item-3:block-8-chunk-1"/>
+          <p:cNvPr id="15" name="mdpr:1-2-dfa474:item-3:block-8-chunk-1"/>
           <p:cNvSpPr txBox="1"/>
           <p:nvPr/>
         </p:nvSpPr>
         <p:spPr>
           <a:xfrm>
-            <a:off x="1133856" y="4600164"/>
-            <a:ext cx="9820656" cy="839785"/>
+            <a:off x="8083296" y="2103120"/>
+            <a:ext cx="2825496" cy="2185416"/>
           </a:xfrm>
           <a:prstGeom prst="rect">
             <a:avLst/>
@@ -22248,61 +21217,7 @@
       </p:sp>
       <p:sp>
         <p:nvSpPr>
-          <p:cNvPr id="9" name="Shape 7"/>
-          <p:cNvSpPr/>
-          <p:nvPr/>
-        </p:nvSpPr>
-        <p:spPr>
-          <a:xfrm>
-            <a:off x="822960" y="1554480"/>
-            <a:ext cx="4937760" cy="73152"/>
-          </a:xfrm>
-          <a:prstGeom prst="rect">
-            <a:avLst/>
-          </a:prstGeom>
-          <a:solidFill>
-            <a:srgbClr val="F43F5E"/>
-          </a:solidFill>
-          <a:ln w="12700">
-            <a:solidFill>
-              <a:srgbClr val="F43F5E">
-                <a:alpha val="0"/>
-              </a:srgbClr>
-            </a:solidFill>
-            <a:prstDash val="solid"/>
-          </a:ln>
-        </p:spPr>
-      </p:sp>
-      <p:sp>
-        <p:nvSpPr>
-          <p:cNvPr id="10" name="Shape 8"/>
-          <p:cNvSpPr/>
-          <p:nvPr/>
-        </p:nvSpPr>
-        <p:spPr>
-          <a:xfrm>
-            <a:off x="6400800" y="1554480"/>
-            <a:ext cx="4937760" cy="73152"/>
-          </a:xfrm>
-          <a:prstGeom prst="rect">
-            <a:avLst/>
-          </a:prstGeom>
-          <a:solidFill>
-            <a:srgbClr val="F43F5E"/>
-          </a:solidFill>
-          <a:ln w="12700">
-            <a:solidFill>
-              <a:srgbClr val="F43F5E">
-                <a:alpha val="0"/>
-              </a:srgbClr>
-            </a:solidFill>
-            <a:prstDash val="solid"/>
-          </a:ln>
-        </p:spPr>
-      </p:sp>
-      <p:sp>
-        <p:nvSpPr>
-          <p:cNvPr id="11" name="mdpr:2-2-149bde:title:__title:2-2-149bde"/>
+          <p:cNvPr id="9" name="mdpr:2-2-149bde:title:__title:2-2-149bde"/>
           <p:cNvSpPr txBox="1"/>
           <p:nvPr/>
         </p:nvSpPr>
@@ -22336,7 +21251,24 @@
                 <a:ea typeface="Pretendard" pitchFamily="34" charset="-122"/>
                 <a:cs typeface="Pretendard" pitchFamily="34" charset="-120"/>
               </a:rPr>
-              <a:t>Pruned Style Families (Cont. 2/2)</a:t>
+              <a:t>Pruned Style Families</a:t>
+            </a:r>
+            <a:pPr algn="ctr" indent="0" marL="0">
+              <a:lnSpc>
+                <a:spcPct val="120000"/>
+              </a:lnSpc>
+              <a:buNone/>
+            </a:pPr>
+            <a:r>
+              <a:rPr lang="en-US" sz="2000" dirty="0">
+                <a:solidFill>
+                  <a:srgbClr val="8F8F8F"/>
+                </a:solidFill>
+                <a:latin typeface="Pretendard" pitchFamily="34" charset="0"/>
+                <a:ea typeface="Pretendard" pitchFamily="34" charset="-122"/>
+                <a:cs typeface="Pretendard" pitchFamily="34" charset="-120"/>
+              </a:rPr>
+              <a:t> (Cont. 2/2)</a:t>
             </a:r>
             <a:endParaRPr lang="en-US" sz="3400" dirty="0"/>
           </a:p>
@@ -22344,14 +21276,14 @@
       </p:sp>
       <p:sp>
         <p:nvSpPr>
-          <p:cNvPr id="12" name="mdpr:2-2-149bde:left:block-8-chunk-2"/>
+          <p:cNvPr id="10" name="mdpr:2-2-149bde:left:block-8-chunk-2"/>
           <p:cNvSpPr txBox="1"/>
           <p:nvPr/>
         </p:nvSpPr>
         <p:spPr>
           <a:xfrm>
-            <a:off x="896112" y="1664208"/>
-            <a:ext cx="4791456" cy="4169664"/>
+            <a:off x="896112" y="1463040"/>
+            <a:ext cx="4791456" cy="4261104"/>
           </a:xfrm>
           <a:prstGeom prst="rect">
             <a:avLst/>
@@ -22403,14 +21335,14 @@
       </p:sp>
       <p:sp>
         <p:nvSpPr>
-          <p:cNvPr id="13" name="mdpr:2-2-149bde:right:block-8-chunk-2"/>
+          <p:cNvPr id="11" name="mdpr:2-2-149bde:right:block-8-chunk-2"/>
           <p:cNvSpPr txBox="1"/>
           <p:nvPr/>
         </p:nvSpPr>
         <p:spPr>
           <a:xfrm>
-            <a:off x="6473952" y="1664208"/>
-            <a:ext cx="4791456" cy="4169664"/>
+            <a:off x="6473952" y="1463040"/>
+            <a:ext cx="4791456" cy="4261104"/>
           </a:xfrm>
           <a:prstGeom prst="rect">
             <a:avLst/>
@@ -22712,16 +21644,148 @@
           </a:ln>
         </p:spPr>
       </p:sp>
-      <p:sp>
-        <p:nvSpPr>
-          <p:cNvPr id="9" name="Shape 7"/>
-          <p:cNvSpPr/>
-          <p:nvPr/>
-        </p:nvSpPr>
-        <p:spPr>
-          <a:xfrm>
-            <a:off x="822960" y="1554480"/>
-            <a:ext cx="4937760" cy="73152"/>
+      <p:pic>
+        <p:nvPicPr>
+          <p:cNvPr id="9" name="Image 0" descr="preencoded.png">    </p:cNvPr>
+          <p:cNvPicPr>
+            <a:picLocks noChangeAspect="1"/>
+          </p:cNvPicPr>
+          <p:nvPr/>
+        </p:nvPicPr>
+        <p:blipFill>
+          <a:blip r:embed="rId1">
+            <a:extLst>
+              <a:ext uri="{96DAC541-7B7A-43D3-8B79-37D633B846F1}">
+                <asvg:svgBlip xmlns:asvg="http://schemas.microsoft.com/office/drawing/2016/SVG/main" r:embed="rId2"/>
+              </a:ext>
+            </a:extLst>
+          </a:blip>
+          <a:stretch>
+            <a:fillRect/>
+          </a:stretch>
+        </p:blipFill>
+        <p:spPr>
+          <a:xfrm>
+            <a:off x="914400" y="2523744"/>
+            <a:ext cx="10241280" cy="1024128"/>
+          </a:xfrm>
+          <a:prstGeom prst="rect">
+            <a:avLst/>
+          </a:prstGeom>
+        </p:spPr>
+      </p:pic>
+      <p:sp>
+        <p:nvSpPr>
+          <p:cNvPr id="10" name="Shape 7"/>
+          <p:cNvSpPr/>
+          <p:nvPr/>
+        </p:nvSpPr>
+        <p:spPr>
+          <a:xfrm>
+            <a:off x="914400" y="2523744"/>
+            <a:ext cx="10241280" cy="1024128"/>
+          </a:xfrm>
+          <a:prstGeom prst="rect">
+            <a:avLst/>
+          </a:prstGeom>
+          <a:solidFill>
+            <a:srgbClr val="FFFFFF">
+              <a:alpha val="0"/>
+            </a:srgbClr>
+          </a:solidFill>
+          <a:ln w="12700">
+            <a:solidFill>
+              <a:srgbClr val="E5E7EB">
+                <a:alpha val="0"/>
+              </a:srgbClr>
+            </a:solidFill>
+            <a:prstDash val="solid"/>
+          </a:ln>
+          <a:effectLst>
+            <a:outerShdw sx="100000" sy="100000" kx="0" ky="0" algn="bl" rotWithShape="0" blurRad="12700" dist="50800" dir="2700000">
+              <a:srgbClr val="000000">
+                <a:alpha val="8000"/>
+              </a:srgbClr>
+            </a:outerShdw>
+          </a:effectLst>
+        </p:spPr>
+      </p:sp>
+      <p:pic>
+        <p:nvPicPr>
+          <p:cNvPr id="11" name="Image 1" descr="preencoded.png">    </p:cNvPr>
+          <p:cNvPicPr>
+            <a:picLocks noChangeAspect="1"/>
+          </p:cNvPicPr>
+          <p:nvPr/>
+        </p:nvPicPr>
+        <p:blipFill>
+          <a:blip r:embed="rId3">
+            <a:extLst>
+              <a:ext uri="{96DAC541-7B7A-43D3-8B79-37D633B846F1}">
+                <asvg:svgBlip xmlns:asvg="http://schemas.microsoft.com/office/drawing/2016/SVG/main" r:embed="rId4"/>
+              </a:ext>
+            </a:extLst>
+          </a:blip>
+          <a:stretch>
+            <a:fillRect/>
+          </a:stretch>
+        </p:blipFill>
+        <p:spPr>
+          <a:xfrm>
+            <a:off x="914400" y="3849624"/>
+            <a:ext cx="10241280" cy="1024128"/>
+          </a:xfrm>
+          <a:prstGeom prst="rect">
+            <a:avLst/>
+          </a:prstGeom>
+        </p:spPr>
+      </p:pic>
+      <p:sp>
+        <p:nvSpPr>
+          <p:cNvPr id="12" name="Shape 8"/>
+          <p:cNvSpPr/>
+          <p:nvPr/>
+        </p:nvSpPr>
+        <p:spPr>
+          <a:xfrm>
+            <a:off x="914400" y="3849624"/>
+            <a:ext cx="10241280" cy="1024128"/>
+          </a:xfrm>
+          <a:prstGeom prst="rect">
+            <a:avLst/>
+          </a:prstGeom>
+          <a:solidFill>
+            <a:srgbClr val="FFFFFF">
+              <a:alpha val="0"/>
+            </a:srgbClr>
+          </a:solidFill>
+          <a:ln w="12700">
+            <a:solidFill>
+              <a:srgbClr val="E5E7EB">
+                <a:alpha val="0"/>
+              </a:srgbClr>
+            </a:solidFill>
+            <a:prstDash val="solid"/>
+          </a:ln>
+          <a:effectLst>
+            <a:outerShdw sx="100000" sy="100000" kx="0" ky="0" algn="bl" rotWithShape="0" blurRad="12700" dist="50800" dir="2700000">
+              <a:srgbClr val="000000">
+                <a:alpha val="8000"/>
+              </a:srgbClr>
+            </a:outerShdw>
+          </a:effectLst>
+        </p:spPr>
+      </p:sp>
+      <p:sp>
+        <p:nvSpPr>
+          <p:cNvPr id="13" name="Shape 9"/>
+          <p:cNvSpPr/>
+          <p:nvPr/>
+        </p:nvSpPr>
+        <p:spPr>
+          <a:xfrm>
+            <a:off x="914400" y="2523744"/>
+            <a:ext cx="73152" cy="1024128"/>
           </a:xfrm>
           <a:prstGeom prst="rect">
             <a:avLst/>
@@ -22741,24 +21805,24 @@
       </p:sp>
       <p:sp>
         <p:nvSpPr>
-          <p:cNvPr id="10" name="Shape 8"/>
-          <p:cNvSpPr/>
-          <p:nvPr/>
-        </p:nvSpPr>
-        <p:spPr>
-          <a:xfrm>
-            <a:off x="6400800" y="1554480"/>
-            <a:ext cx="4937760" cy="73152"/>
-          </a:xfrm>
-          <a:prstGeom prst="rect">
-            <a:avLst/>
-          </a:prstGeom>
-          <a:solidFill>
-            <a:srgbClr val="F43F5E"/>
-          </a:solidFill>
-          <a:ln w="12700">
-            <a:solidFill>
-              <a:srgbClr val="F43F5E">
+          <p:cNvPr id="14" name="Shape 10"/>
+          <p:cNvSpPr/>
+          <p:nvPr/>
+        </p:nvSpPr>
+        <p:spPr>
+          <a:xfrm>
+            <a:off x="914400" y="3849624"/>
+            <a:ext cx="73152" cy="1024128"/>
+          </a:xfrm>
+          <a:prstGeom prst="rect">
+            <a:avLst/>
+          </a:prstGeom>
+          <a:solidFill>
+            <a:srgbClr val="38BDF8"/>
+          </a:solidFill>
+          <a:ln w="12700">
+            <a:solidFill>
+              <a:srgbClr val="38BDF8">
                 <a:alpha val="0"/>
               </a:srgbClr>
             </a:solidFill>
@@ -22768,7 +21832,7 @@
       </p:sp>
       <p:sp>
         <p:nvSpPr>
-          <p:cNvPr id="11" name="mdpr:1-2-5a84f1:title:__title:1-2-5a84f1"/>
+          <p:cNvPr id="15" name="mdpr:1-2-5a84f1:title:__title:1-2-5a84f1"/>
           <p:cNvSpPr txBox="1"/>
           <p:nvPr/>
         </p:nvSpPr>
@@ -22810,14 +21874,14 @@
       </p:sp>
       <p:sp>
         <p:nvSpPr>
-          <p:cNvPr id="12" name="mdpr:1-2-5a84f1:left:block-10-chunk-1"/>
+          <p:cNvPr id="16" name="mdpr:1-2-5a84f1:item-1:block-10-chunk-1"/>
           <p:cNvSpPr txBox="1"/>
           <p:nvPr/>
         </p:nvSpPr>
         <p:spPr>
           <a:xfrm>
-            <a:off x="896112" y="1664208"/>
-            <a:ext cx="4791456" cy="4169664"/>
+            <a:off x="1133856" y="2615916"/>
+            <a:ext cx="9820656" cy="839785"/>
           </a:xfrm>
           <a:prstGeom prst="rect">
             <a:avLst/>
@@ -22826,7 +21890,7 @@
           <a:ln/>
         </p:spPr>
         <p:txBody>
-          <a:bodyPr wrap="square" lIns="0" tIns="25400" rIns="25400" bIns="0" rtlCol="0" anchor="t"/>
+          <a:bodyPr wrap="square" lIns="0" tIns="25400" rIns="25400" bIns="0" rtlCol="0" anchor="ctr"/>
           <a:lstStyle/>
           <a:p>
             <a:pPr algn="l" indent="0" marL="0">
@@ -22844,7 +21908,7 @@
                 <a:ea typeface="Pretendard" pitchFamily="34" charset="-122"/>
                 <a:cs typeface="Pretendard" pitchFamily="34" charset="-120"/>
               </a:rPr>
-              <a:t>- Headings</a:t>
+              <a:t>Headings</a:t>
             </a:r>
             <a:pPr algn="l" indent="0" marL="0">
               <a:lnSpc>
@@ -22869,14 +21933,14 @@
       </p:sp>
       <p:sp>
         <p:nvSpPr>
-          <p:cNvPr id="13" name="mdpr:1-2-5a84f1:right:block-10-chunk-1"/>
+          <p:cNvPr id="17" name="mdpr:1-2-5a84f1:item-2:block-10-chunk-1"/>
           <p:cNvSpPr txBox="1"/>
           <p:nvPr/>
         </p:nvSpPr>
         <p:spPr>
           <a:xfrm>
-            <a:off x="6473952" y="1664208"/>
-            <a:ext cx="4791456" cy="4169664"/>
+            <a:off x="1133856" y="3941796"/>
+            <a:ext cx="9820656" cy="839785"/>
           </a:xfrm>
           <a:prstGeom prst="rect">
             <a:avLst/>
@@ -22885,7 +21949,7 @@
           <a:ln/>
         </p:spPr>
         <p:txBody>
-          <a:bodyPr wrap="square" lIns="0" tIns="25400" rIns="25400" bIns="0" rtlCol="0" anchor="t"/>
+          <a:bodyPr wrap="square" lIns="0" tIns="25400" rIns="25400" bIns="0" rtlCol="0" anchor="ctr"/>
           <a:lstStyle/>
           <a:p>
             <a:pPr algn="l" indent="0" marL="0">
@@ -22903,7 +21967,7 @@
                 <a:ea typeface="Pretendard" pitchFamily="34" charset="-122"/>
                 <a:cs typeface="Pretendard" pitchFamily="34" charset="-120"/>
               </a:rPr>
-              <a:t>- Lists</a:t>
+              <a:t>Lists</a:t>
             </a:r>
             <a:pPr algn="l" indent="0" marL="0">
               <a:lnSpc>

</xml_diff>